<commit_message>
Ship compliance workflows and demo seed
</commit_message>
<xml_diff>
--- a/market-research/Leasium_Financials.pptx
+++ b/market-research/Leasium_Financials.pptx
@@ -4,6 +4,9 @@
   <p:sldMasterIdLst>
     <p:sldMasterId id="2147483648" r:id="rId1"/>
   </p:sldMasterIdLst>
+  <p:notesMasterIdLst>
+    <p:notesMasterId r:id="rId7"/>
+  </p:notesMasterIdLst>
   <p:sldIdLst>
     <p:sldId id="256" r:id="rId2"/>
     <p:sldId id="257" r:id="rId3"/>
@@ -11,9 +14,6 @@
     <p:sldId id="259" r:id="rId5"/>
     <p:sldId id="260" r:id="rId6"/>
   </p:sldIdLst>
-  <p:notesMasterIdLst>
-    <p:notesMasterId r:id="rId7"/>
-  </p:notesMasterIdLst>
   <p:sldSz cx="12192000" cy="6858000"/>
   <p:notesSz cx="6858000" cy="12192000"/>
   <p:defaultTextStyle>
@@ -108,13 +108,20 @@
       </a:defRPr>
     </a:lvl9pPr>
   </p:defaultTextStyle>
+  <p:extLst>
+    <p:ext uri="{EFAFB233-063F-42B5-8137-9DF3F51BA10A}">
+      <p15:sldGuideLst xmlns:p15="http://schemas.microsoft.com/office/powerpoint/2012/main"/>
+    </p:ext>
+  </p:extLst>
 </p:presentation>
 </file>
 
 <file path=ppt/charts/chart1.xml><?xml version="1.0" encoding="utf-8"?>
-<c:chartSpace xmlns:c="http://schemas.openxmlformats.org/drawingml/2006/chart" xmlns:a="http://schemas.openxmlformats.org/drawingml/2006/main" xmlns:r="http://schemas.openxmlformats.org/officeDocument/2006/relationships">
+<c:chartSpace xmlns:c="http://schemas.openxmlformats.org/drawingml/2006/chart" xmlns:a="http://schemas.openxmlformats.org/drawingml/2006/main" xmlns:r="http://schemas.openxmlformats.org/officeDocument/2006/relationships" xmlns:c16r2="http://schemas.microsoft.com/office/drawing/2015/06/chart">
   <c:date1904 val="0"/>
+  <c:lang val="en-GB"/>
   <c:roundedCorners val="1"/>
+  <c:style val="2"/>
   <c:chart>
     <c:autoTitleDeleted val="1"/>
     <c:plotArea>
@@ -144,30 +151,6 @@
             <a:effectLst/>
           </c:spPr>
           <c:invertIfNegative val="0"/>
-          <c:dLbls>
-            <c:numFmt formatCode="$0.0,,&quot;M&quot;" sourceLinked="0"/>
-            <c:txPr>
-              <a:bodyPr/>
-              <a:lstStyle/>
-              <a:p>
-                <a:pPr>
-                  <a:defRPr b="1" i="0" strike="noStrike" sz="1400" u="none">
-                    <a:solidFill>
-                      <a:srgbClr val="1E293B"/>
-                    </a:solidFill>
-                    <a:latin typeface="Calibri"/>
-                  </a:defRPr>
-                </a:pPr>
-              </a:p>
-            </c:txPr>
-            <c:showLegendKey val="0"/>
-            <c:showVal val="1"/>
-            <c:showCatName val="0"/>
-            <c:showSerName val="0"/>
-            <c:showPercent val="0"/>
-            <c:showBubbleSize val="0"/>
-            <c:showLeaderLines val="0"/>
-          </c:dLbls>
           <c:dPt>
             <c:idx val="0"/>
             <c:invertIfNegative val="0"/>
@@ -178,6 +161,11 @@
               </a:solidFill>
               <a:effectLst/>
             </c:spPr>
+            <c:extLst>
+              <c:ext xmlns:c16="http://schemas.microsoft.com/office/drawing/2014/chart" uri="{C3380CC4-5D6E-409C-BE32-E72D297353CC}">
+                <c16:uniqueId val="{00000001-DEDE-1A46-B0F7-9507C25C0CBD}"/>
+              </c:ext>
+            </c:extLst>
           </c:dPt>
           <c:dPt>
             <c:idx val="1"/>
@@ -189,6 +177,11 @@
               </a:solidFill>
               <a:effectLst/>
             </c:spPr>
+            <c:extLst>
+              <c:ext xmlns:c16="http://schemas.microsoft.com/office/drawing/2014/chart" uri="{C3380CC4-5D6E-409C-BE32-E72D297353CC}">
+                <c16:uniqueId val="{00000003-DEDE-1A46-B0F7-9507C25C0CBD}"/>
+              </c:ext>
+            </c:extLst>
           </c:dPt>
           <c:dPt>
             <c:idx val="2"/>
@@ -200,25 +193,65 @@
               </a:solidFill>
               <a:effectLst/>
             </c:spPr>
+            <c:extLst>
+              <c:ext xmlns:c16="http://schemas.microsoft.com/office/drawing/2014/chart" uri="{C3380CC4-5D6E-409C-BE32-E72D297353CC}">
+                <c16:uniqueId val="{00000005-DEDE-1A46-B0F7-9507C25C0CBD}"/>
+              </c:ext>
+            </c:extLst>
           </c:dPt>
+          <c:dLbls>
+            <c:numFmt formatCode="\$0.0,,&quot;M&quot;" sourceLinked="0"/>
+            <c:spPr>
+              <a:noFill/>
+              <a:ln>
+                <a:noFill/>
+              </a:ln>
+              <a:effectLst/>
+            </c:spPr>
+            <c:txPr>
+              <a:bodyPr/>
+              <a:lstStyle/>
+              <a:p>
+                <a:pPr>
+                  <a:defRPr sz="1400" b="1" i="0" u="none" strike="noStrike">
+                    <a:solidFill>
+                      <a:srgbClr val="1E293B"/>
+                    </a:solidFill>
+                    <a:latin typeface="Calibri"/>
+                  </a:defRPr>
+                </a:pPr>
+                <a:endParaRPr lang="en-US"/>
+              </a:p>
+            </c:txPr>
+            <c:showLegendKey val="0"/>
+            <c:showVal val="1"/>
+            <c:showCatName val="0"/>
+            <c:showSerName val="0"/>
+            <c:showPercent val="0"/>
+            <c:showBubbleSize val="0"/>
+            <c:showLeaderLines val="0"/>
+            <c:extLst>
+              <c:ext xmlns:c15="http://schemas.microsoft.com/office/drawing/2012/chart" uri="{CE6537A1-D6FC-4f65-9D91-7224C49458BB}">
+                <c15:showLeaderLines val="0"/>
+              </c:ext>
+            </c:extLst>
+          </c:dLbls>
           <c:cat>
-            <c:multiLvlStrRef>
+            <c:strRef>
               <c:f>Sheet1!$A$2:$A$4</c:f>
-              <c:multiLvlStrCache>
+              <c:strCache>
                 <c:ptCount val="3"/>
-                <c:lvl>
-                  <c:pt idx="0">
-                    <c:v>$3 / mo</c:v>
-                  </c:pt>
-                  <c:pt idx="1">
-                    <c:v>$4 / mo</c:v>
-                  </c:pt>
-                  <c:pt idx="2">
-                    <c:v>$5 / mo</c:v>
-                  </c:pt>
-                </c:lvl>
-              </c:multiLvlStrCache>
-            </c:multiLvlStrRef>
+                <c:pt idx="0">
+                  <c:v>$3 / mo</c:v>
+                </c:pt>
+                <c:pt idx="1">
+                  <c:v>$3.50 / mo</c:v>
+                </c:pt>
+                <c:pt idx="2">
+                  <c:v>$4 / mo</c:v>
+                </c:pt>
+              </c:strCache>
+            </c:strRef>
           </c:cat>
           <c:val>
             <c:numRef>
@@ -227,47 +260,34 @@
                 <c:formatCode>General</c:formatCode>
                 <c:ptCount val="3"/>
                 <c:pt idx="0">
-                  <c:v>3600000</c:v>
+                  <c:v>18000000</c:v>
                 </c:pt>
                 <c:pt idx="1">
-                  <c:v>4800000</c:v>
+                  <c:v>21000000</c:v>
                 </c:pt>
                 <c:pt idx="2">
-                  <c:v>6000000</c:v>
+                  <c:v>24000000</c:v>
                 </c:pt>
               </c:numCache>
             </c:numRef>
           </c:val>
+          <c:extLst>
+            <c:ext xmlns:c16="http://schemas.microsoft.com/office/drawing/2014/chart" uri="{C3380CC4-5D6E-409C-BE32-E72D297353CC}">
+              <c16:uniqueId val="{00000006-DEDE-1A46-B0F7-9507C25C0CBD}"/>
+            </c:ext>
+          </c:extLst>
         </c:ser>
         <c:dLbls>
-          <c:numFmt formatCode="$0.0,,&quot;M&quot;" sourceLinked="0"/>
-          <c:txPr>
-            <a:bodyPr/>
-            <a:lstStyle/>
-            <a:p>
-              <a:pPr>
-                <a:defRPr b="1" i="0" strike="noStrike" sz="1400" u="none">
-                  <a:solidFill>
-                    <a:srgbClr val="1E293B"/>
-                  </a:solidFill>
-                  <a:latin typeface="Calibri"/>
-                </a:defRPr>
-              </a:pPr>
-            </a:p>
-          </c:txPr>
           <c:showLegendKey val="0"/>
           <c:showVal val="1"/>
           <c:showCatName val="0"/>
           <c:showSerName val="0"/>
           <c:showPercent val="0"/>
           <c:showBubbleSize val="0"/>
-          <c:showLeaderLines val="0"/>
         </c:dLbls>
         <c:gapWidth val="55"/>
-        <c:overlap val="0"/>
         <c:axId val="2094734554"/>
         <c:axId val="2094734552"/>
-        <c:axId val="2094734556"/>
       </c:barChart>
       <c:catAx>
         <c:axId val="2094734554"/>
@@ -308,6 +328,7 @@
         <c:crosses val="autoZero"/>
         <c:auto val="1"/>
         <c:lblAlgn val="ctr"/>
+        <c:lblOffset val="100"/>
         <c:noMultiLvlLbl val="1"/>
       </c:catAx>
       <c:valAx>
@@ -321,30 +342,6 @@
         <c:majorTickMark val="out"/>
         <c:minorTickMark val="none"/>
         <c:tickLblPos val="nextTo"/>
-        <c:spPr>
-          <a:ln w="12700" cap="flat">
-            <a:solidFill>
-              <a:srgbClr val="888888"/>
-            </a:solidFill>
-            <a:prstDash val="solid"/>
-            <a:round/>
-          </a:ln>
-        </c:spPr>
-        <c:txPr>
-          <a:bodyPr/>
-          <a:lstStyle/>
-          <a:p>
-            <a:pPr>
-              <a:defRPr sz="1200" b="0" i="0" u="none" strike="noStrike">
-                <a:solidFill>
-                  <a:srgbClr val="000000"/>
-                </a:solidFill>
-                <a:latin typeface="Arial"/>
-              </a:defRPr>
-            </a:pPr>
-            <a:endParaRPr lang="en-US"/>
-          </a:p>
-        </c:txPr>
         <c:crossAx val="2094734554"/>
         <c:crosses val="autoZero"/>
         <c:crossBetween val="between"/>
@@ -361,6 +358,7 @@
     </c:plotArea>
     <c:plotVisOnly val="1"/>
     <c:dispBlanksAs val="span"/>
+    <c:showDLblsOverMax val="1"/>
   </c:chart>
   <c:spPr>
     <a:solidFill>
@@ -378,9 +376,11 @@
 </file>
 
 <file path=ppt/charts/chart2.xml><?xml version="1.0" encoding="utf-8"?>
-<c:chartSpace xmlns:c="http://schemas.openxmlformats.org/drawingml/2006/chart" xmlns:a="http://schemas.openxmlformats.org/drawingml/2006/main" xmlns:r="http://schemas.openxmlformats.org/officeDocument/2006/relationships">
+<c:chartSpace xmlns:c="http://schemas.openxmlformats.org/drawingml/2006/chart" xmlns:a="http://schemas.openxmlformats.org/drawingml/2006/main" xmlns:r="http://schemas.openxmlformats.org/officeDocument/2006/relationships" xmlns:c16r2="http://schemas.microsoft.com/office/drawing/2015/06/chart">
   <c:date1904 val="0"/>
+  <c:lang val="en-GB"/>
   <c:roundedCorners val="1"/>
+  <c:style val="2"/>
   <c:chart>
     <c:autoTitleDeleted val="1"/>
     <c:plotArea>
@@ -410,30 +410,6 @@
             <a:effectLst/>
           </c:spPr>
           <c:invertIfNegative val="0"/>
-          <c:dLbls>
-            <c:numFmt formatCode="$0.00" sourceLinked="0"/>
-            <c:txPr>
-              <a:bodyPr/>
-              <a:lstStyle/>
-              <a:p>
-                <a:pPr>
-                  <a:defRPr b="1" i="0" strike="noStrike" sz="1100" u="none">
-                    <a:solidFill>
-                      <a:srgbClr val="1E293B"/>
-                    </a:solidFill>
-                    <a:latin typeface="Calibri"/>
-                  </a:defRPr>
-                </a:pPr>
-              </a:p>
-            </c:txPr>
-            <c:showLegendKey val="0"/>
-            <c:showVal val="1"/>
-            <c:showCatName val="0"/>
-            <c:showSerName val="0"/>
-            <c:showPercent val="0"/>
-            <c:showBubbleSize val="0"/>
-            <c:showLeaderLines val="0"/>
-          </c:dLbls>
           <c:dPt>
             <c:idx val="0"/>
             <c:invertIfNegative val="0"/>
@@ -444,6 +420,11 @@
               </a:solidFill>
               <a:effectLst/>
             </c:spPr>
+            <c:extLst>
+              <c:ext xmlns:c16="http://schemas.microsoft.com/office/drawing/2014/chart" uri="{C3380CC4-5D6E-409C-BE32-E72D297353CC}">
+                <c16:uniqueId val="{00000001-1EC2-C546-9BD1-E9A8E7B45038}"/>
+              </c:ext>
+            </c:extLst>
           </c:dPt>
           <c:dPt>
             <c:idx val="1"/>
@@ -455,6 +436,11 @@
               </a:solidFill>
               <a:effectLst/>
             </c:spPr>
+            <c:extLst>
+              <c:ext xmlns:c16="http://schemas.microsoft.com/office/drawing/2014/chart" uri="{C3380CC4-5D6E-409C-BE32-E72D297353CC}">
+                <c16:uniqueId val="{00000003-1EC2-C546-9BD1-E9A8E7B45038}"/>
+              </c:ext>
+            </c:extLst>
           </c:dPt>
           <c:dPt>
             <c:idx val="2"/>
@@ -466,6 +452,11 @@
               </a:solidFill>
               <a:effectLst/>
             </c:spPr>
+            <c:extLst>
+              <c:ext xmlns:c16="http://schemas.microsoft.com/office/drawing/2014/chart" uri="{C3380CC4-5D6E-409C-BE32-E72D297353CC}">
+                <c16:uniqueId val="{00000005-1EC2-C546-9BD1-E9A8E7B45038}"/>
+              </c:ext>
+            </c:extLst>
           </c:dPt>
           <c:dPt>
             <c:idx val="3"/>
@@ -477,6 +468,11 @@
               </a:solidFill>
               <a:effectLst/>
             </c:spPr>
+            <c:extLst>
+              <c:ext xmlns:c16="http://schemas.microsoft.com/office/drawing/2014/chart" uri="{C3380CC4-5D6E-409C-BE32-E72D297353CC}">
+                <c16:uniqueId val="{00000007-1EC2-C546-9BD1-E9A8E7B45038}"/>
+              </c:ext>
+            </c:extLst>
           </c:dPt>
           <c:dPt>
             <c:idx val="4"/>
@@ -488,6 +484,11 @@
               </a:solidFill>
               <a:effectLst/>
             </c:spPr>
+            <c:extLst>
+              <c:ext xmlns:c16="http://schemas.microsoft.com/office/drawing/2014/chart" uri="{C3380CC4-5D6E-409C-BE32-E72D297353CC}">
+                <c16:uniqueId val="{00000009-1EC2-C546-9BD1-E9A8E7B45038}"/>
+              </c:ext>
+            </c:extLst>
           </c:dPt>
           <c:dPt>
             <c:idx val="5"/>
@@ -499,6 +500,11 @@
               </a:solidFill>
               <a:effectLst/>
             </c:spPr>
+            <c:extLst>
+              <c:ext xmlns:c16="http://schemas.microsoft.com/office/drawing/2014/chart" uri="{C3380CC4-5D6E-409C-BE32-E72D297353CC}">
+                <c16:uniqueId val="{0000000B-1EC2-C546-9BD1-E9A8E7B45038}"/>
+              </c:ext>
+            </c:extLst>
           </c:dPt>
           <c:dPt>
             <c:idx val="6"/>
@@ -510,6 +516,11 @@
               </a:solidFill>
               <a:effectLst/>
             </c:spPr>
+            <c:extLst>
+              <c:ext xmlns:c16="http://schemas.microsoft.com/office/drawing/2014/chart" uri="{C3380CC4-5D6E-409C-BE32-E72D297353CC}">
+                <c16:uniqueId val="{0000000D-1EC2-C546-9BD1-E9A8E7B45038}"/>
+              </c:ext>
+            </c:extLst>
           </c:dPt>
           <c:dPt>
             <c:idx val="7"/>
@@ -521,6 +532,11 @@
               </a:solidFill>
               <a:effectLst/>
             </c:spPr>
+            <c:extLst>
+              <c:ext xmlns:c16="http://schemas.microsoft.com/office/drawing/2014/chart" uri="{C3380CC4-5D6E-409C-BE32-E72D297353CC}">
+                <c16:uniqueId val="{0000000F-1EC2-C546-9BD1-E9A8E7B45038}"/>
+              </c:ext>
+            </c:extLst>
           </c:dPt>
           <c:dPt>
             <c:idx val="8"/>
@@ -532,6 +548,11 @@
               </a:solidFill>
               <a:effectLst/>
             </c:spPr>
+            <c:extLst>
+              <c:ext xmlns:c16="http://schemas.microsoft.com/office/drawing/2014/chart" uri="{C3380CC4-5D6E-409C-BE32-E72D297353CC}">
+                <c16:uniqueId val="{00000011-1EC2-C546-9BD1-E9A8E7B45038}"/>
+              </c:ext>
+            </c:extLst>
           </c:dPt>
           <c:dPt>
             <c:idx val="9"/>
@@ -543,6 +564,11 @@
               </a:solidFill>
               <a:effectLst/>
             </c:spPr>
+            <c:extLst>
+              <c:ext xmlns:c16="http://schemas.microsoft.com/office/drawing/2014/chart" uri="{C3380CC4-5D6E-409C-BE32-E72D297353CC}">
+                <c16:uniqueId val="{00000013-1EC2-C546-9BD1-E9A8E7B45038}"/>
+              </c:ext>
+            </c:extLst>
           </c:dPt>
           <c:dPt>
             <c:idx val="10"/>
@@ -554,49 +580,89 @@
               </a:solidFill>
               <a:effectLst/>
             </c:spPr>
+            <c:extLst>
+              <c:ext xmlns:c16="http://schemas.microsoft.com/office/drawing/2014/chart" uri="{C3380CC4-5D6E-409C-BE32-E72D297353CC}">
+                <c16:uniqueId val="{00000015-1EC2-C546-9BD1-E9A8E7B45038}"/>
+              </c:ext>
+            </c:extLst>
           </c:dPt>
+          <c:dLbls>
+            <c:numFmt formatCode="\$0.00" sourceLinked="0"/>
+            <c:spPr>
+              <a:noFill/>
+              <a:ln>
+                <a:noFill/>
+              </a:ln>
+              <a:effectLst/>
+            </c:spPr>
+            <c:txPr>
+              <a:bodyPr/>
+              <a:lstStyle/>
+              <a:p>
+                <a:pPr>
+                  <a:defRPr sz="1100" b="1" i="0" u="none" strike="noStrike">
+                    <a:solidFill>
+                      <a:srgbClr val="1E293B"/>
+                    </a:solidFill>
+                    <a:latin typeface="Calibri"/>
+                  </a:defRPr>
+                </a:pPr>
+                <a:endParaRPr lang="en-US"/>
+              </a:p>
+            </c:txPr>
+            <c:showLegendKey val="0"/>
+            <c:showVal val="1"/>
+            <c:showCatName val="0"/>
+            <c:showSerName val="0"/>
+            <c:showPercent val="0"/>
+            <c:showBubbleSize val="0"/>
+            <c:showLeaderLines val="0"/>
+            <c:extLst>
+              <c:ext xmlns:c15="http://schemas.microsoft.com/office/drawing/2012/chart" uri="{CE6537A1-D6FC-4f65-9D91-7224C49458BB}">
+                <c15:showLeaderLines val="0"/>
+              </c:ext>
+            </c:extLst>
+          </c:dLbls>
           <c:cat>
-            <c:multiLvlStrRef>
+            <c:strRef>
               <c:f>Sheet1!$A$2:$A$12</c:f>
-              <c:multiLvlStrCache>
+              <c:strCache>
                 <c:ptCount val="11"/>
-                <c:lvl>
-                  <c:pt idx="0">
-                    <c:v>TenantCloud (US)</c:v>
-                  </c:pt>
-                  <c:pt idx="1">
-                    <c:v>Buildium (US)</c:v>
-                  </c:pt>
-                  <c:pt idx="2">
-                    <c:v>Leasium — large agency</c:v>
-                  </c:pt>
-                  <c:pt idx="3">
-                    <c:v>Leasium — small agency</c:v>
-                  </c:pt>
-                  <c:pt idx="4">
-                    <c:v>Hemlane (US)</c:v>
-                  </c:pt>
-                  <c:pt idx="5">
-                    <c:v>Leasium — private landlord</c:v>
-                  </c:pt>
-                  <c:pt idx="6">
-                    <c:v>DoorLoop (US)</c:v>
-                  </c:pt>
-                  <c:pt idx="7">
-                    <c:v>PropertyMe (AU)</c:v>
-                  </c:pt>
-                  <c:pt idx="8">
-                    <c:v>Re-Leased (commercial)</c:v>
-                  </c:pt>
-                  <c:pt idx="9">
-                    <c:v>RentingSmart (AU)</c:v>
-                  </c:pt>
-                  <c:pt idx="10">
-                    <c:v>RentBetter (AU)</c:v>
-                  </c:pt>
-                </c:lvl>
-              </c:multiLvlStrCache>
-            </c:multiLvlStrRef>
+                <c:pt idx="0">
+                  <c:v>TenantCloud (US)</c:v>
+                </c:pt>
+                <c:pt idx="1">
+                  <c:v>Buildium (US)</c:v>
+                </c:pt>
+                <c:pt idx="2">
+                  <c:v>Leasium — large agency</c:v>
+                </c:pt>
+                <c:pt idx="3">
+                  <c:v>Leasium — small agency</c:v>
+                </c:pt>
+                <c:pt idx="4">
+                  <c:v>Hemlane (US)</c:v>
+                </c:pt>
+                <c:pt idx="5">
+                  <c:v>Leasium — private landlord</c:v>
+                </c:pt>
+                <c:pt idx="6">
+                  <c:v>DoorLoop (US)</c:v>
+                </c:pt>
+                <c:pt idx="7">
+                  <c:v>PropertyMe (AU)</c:v>
+                </c:pt>
+                <c:pt idx="8">
+                  <c:v>Re-Leased (commercial)</c:v>
+                </c:pt>
+                <c:pt idx="9">
+                  <c:v>RentingSmart (AU)</c:v>
+                </c:pt>
+                <c:pt idx="10">
+                  <c:v>RentBetter (AU)</c:v>
+                </c:pt>
+              </c:strCache>
+            </c:strRef>
           </c:cat>
           <c:val>
             <c:numRef>
@@ -626,7 +692,7 @@
                   <c:v>6.9</c:v>
                 </c:pt>
                 <c:pt idx="7">
-                  <c:v>8.8</c:v>
+                  <c:v>8.8000000000000007</c:v>
                 </c:pt>
                 <c:pt idx="8">
                   <c:v>18</c:v>
@@ -640,36 +706,23 @@
               </c:numCache>
             </c:numRef>
           </c:val>
+          <c:extLst>
+            <c:ext xmlns:c16="http://schemas.microsoft.com/office/drawing/2014/chart" uri="{C3380CC4-5D6E-409C-BE32-E72D297353CC}">
+              <c16:uniqueId val="{00000016-1EC2-C546-9BD1-E9A8E7B45038}"/>
+            </c:ext>
+          </c:extLst>
         </c:ser>
         <c:dLbls>
-          <c:numFmt formatCode="$0.00" sourceLinked="0"/>
-          <c:txPr>
-            <a:bodyPr/>
-            <a:lstStyle/>
-            <a:p>
-              <a:pPr>
-                <a:defRPr b="1" i="0" strike="noStrike" sz="1100" u="none">
-                  <a:solidFill>
-                    <a:srgbClr val="1E293B"/>
-                  </a:solidFill>
-                  <a:latin typeface="Calibri"/>
-                </a:defRPr>
-              </a:pPr>
-            </a:p>
-          </c:txPr>
           <c:showLegendKey val="0"/>
           <c:showVal val="1"/>
           <c:showCatName val="0"/>
           <c:showSerName val="0"/>
           <c:showPercent val="0"/>
           <c:showBubbleSize val="0"/>
-          <c:showLeaderLines val="0"/>
         </c:dLbls>
         <c:gapWidth val="40"/>
-        <c:overlap val="0"/>
         <c:axId val="2094734554"/>
         <c:axId val="2094734552"/>
-        <c:axId val="2094734556"/>
       </c:barChart>
       <c:catAx>
         <c:axId val="2094734554"/>
@@ -710,6 +763,7 @@
         <c:crosses val="autoZero"/>
         <c:auto val="1"/>
         <c:lblAlgn val="ctr"/>
+        <c:lblOffset val="100"/>
         <c:noMultiLvlLbl val="1"/>
       </c:catAx>
       <c:valAx>
@@ -723,30 +777,6 @@
         <c:majorTickMark val="out"/>
         <c:minorTickMark val="none"/>
         <c:tickLblPos val="low"/>
-        <c:spPr>
-          <a:ln w="12700" cap="flat">
-            <a:solidFill>
-              <a:srgbClr val="888888"/>
-            </a:solidFill>
-            <a:prstDash val="solid"/>
-            <a:round/>
-          </a:ln>
-        </c:spPr>
-        <c:txPr>
-          <a:bodyPr/>
-          <a:lstStyle/>
-          <a:p>
-            <a:pPr>
-              <a:defRPr sz="1200" b="0" i="0" u="none" strike="noStrike">
-                <a:solidFill>
-                  <a:srgbClr val="000000"/>
-                </a:solidFill>
-                <a:latin typeface="Arial"/>
-              </a:defRPr>
-            </a:pPr>
-            <a:endParaRPr lang="en-US"/>
-          </a:p>
-        </c:txPr>
         <c:crossAx val="2094734554"/>
         <c:crosses val="autoZero"/>
         <c:crossBetween val="between"/>
@@ -763,6 +793,7 @@
     </c:plotArea>
     <c:plotVisOnly val="1"/>
     <c:dispBlanksAs val="span"/>
+    <c:showDLblsOverMax val="1"/>
   </c:chart>
   <c:spPr>
     <a:solidFill>
@@ -801,234 +832,10 @@
           <a:chExt cx="0" cy="0"/>
         </a:xfrm>
       </p:grpSpPr>
-      <p:sp>
-        <p:nvSpPr>
-          <p:cNvPr id="2" name="Header Placeholder 1"/>
-          <p:cNvSpPr>
-            <a:spLocks noGrp="1"/>
-          </p:cNvSpPr>
-          <p:nvPr>
-            <p:ph type="hdr" sz="quarter"/>
-          </p:nvPr>
-        </p:nvSpPr>
-        <p:spPr>
-          <a:xfrm>
-            <a:off x="0" y="0"/>
-            <a:ext cx="2971800" cy="458788"/>
-          </a:xfrm>
-          <a:prstGeom prst="rect">
-            <a:avLst/>
-          </a:prstGeom>
-        </p:spPr>
-        <p:txBody>
-          <a:bodyPr vert="horz" lIns="91440" tIns="45720" rIns="91440" bIns="45720" rtlCol="0"/>
-          <a:lstStyle>
-            <a:lvl1pPr algn="l">
-              <a:defRPr sz="1200"/>
-            </a:lvl1pPr>
-          </a:lstStyle>
-          <a:p>
-            <a:endParaRPr lang="en-US"/>
-          </a:p>
-        </p:txBody>
-      </p:sp>
-      <p:sp>
-        <p:nvSpPr>
-          <p:cNvPr id="3" name="Date Placeholder 2"/>
-          <p:cNvSpPr>
-            <a:spLocks noGrp="1"/>
-          </p:cNvSpPr>
-          <p:nvPr>
-            <p:ph type="dt" idx="1"/>
-          </p:nvPr>
-        </p:nvSpPr>
-        <p:spPr>
-          <a:xfrm>
-            <a:off x="3884613" y="0"/>
-            <a:ext cx="2971800" cy="458788"/>
-          </a:xfrm>
-          <a:prstGeom prst="rect">
-            <a:avLst/>
-          </a:prstGeom>
-        </p:spPr>
-        <p:txBody>
-          <a:bodyPr vert="horz" lIns="91440" tIns="45720" rIns="91440" bIns="45720" rtlCol="0"/>
-          <a:lstStyle>
-            <a:lvl1pPr algn="r">
-              <a:defRPr sz="1200"/>
-            </a:lvl1pPr>
-          </a:lstStyle>
-          <a:p>
-            <a:fld id="{5282F153-3F37-0F45-9E97-73ACFA13230C}" type="datetimeFigureOut">
-              <a:rPr lang="en-US"/>
-              <a:t>7/23/19</a:t>
-            </a:fld>
-            <a:endParaRPr lang="en-US"/>
-          </a:p>
-        </p:txBody>
-      </p:sp>
-      <p:sp>
-        <p:nvSpPr>
-          <p:cNvPr id="4" name="Slide Image Placeholder 3"/>
-          <p:cNvSpPr>
-            <a:spLocks noGrp="1" noRot="1" noChangeAspect="1"/>
-          </p:cNvSpPr>
-          <p:nvPr>
-            <p:ph type="sldImg" idx="2"/>
-          </p:nvPr>
-        </p:nvSpPr>
-        <p:spPr>
-          <a:xfrm>
-            <a:off x="685800" y="1143000"/>
-            <a:ext cx="5486400" cy="3086100"/>
-          </a:xfrm>
-          <a:prstGeom prst="rect">
-            <a:avLst/>
-          </a:prstGeom>
-          <a:noFill/>
-          <a:ln w="12700">
-            <a:solidFill>
-              <a:prstClr val="black"/>
-            </a:solidFill>
-          </a:ln>
-        </p:spPr>
-        <p:txBody>
-          <a:bodyPr vert="horz" lIns="91440" tIns="45720" rIns="91440" bIns="45720" rtlCol="0" anchor="ctr"/>
-          <a:lstStyle/>
-          <a:p>
-            <a:endParaRPr lang="en-US"/>
-          </a:p>
-        </p:txBody>
-      </p:sp>
-      <p:sp>
-        <p:nvSpPr>
-          <p:cNvPr id="5" name="Notes Placeholder 4"/>
-          <p:cNvSpPr>
-            <a:spLocks noGrp="1"/>
-          </p:cNvSpPr>
-          <p:nvPr>
-            <p:ph type="body" sz="quarter" idx="3"/>
-          </p:nvPr>
-        </p:nvSpPr>
-        <p:spPr>
-          <a:xfrm>
-            <a:off x="685800" y="4400550"/>
-            <a:ext cx="5486400" cy="3600450"/>
-          </a:xfrm>
-          <a:prstGeom prst="rect">
-            <a:avLst/>
-          </a:prstGeom>
-        </p:spPr>
-        <p:txBody>
-          <a:bodyPr vert="horz" lIns="91440" tIns="45720" rIns="91440" bIns="45720" rtlCol="0"/>
-          <a:lstStyle/>
-          <a:p>
-            <a:pPr lvl="0"/>
-            <a:r>
-              <a:rPr lang="en-US"/>
-              <a:t>Click to edit Master text styles</a:t>
-            </a:r>
-          </a:p>
-          <a:p>
-            <a:pPr lvl="1"/>
-            <a:r>
-              <a:rPr lang="en-US"/>
-              <a:t>Second level</a:t>
-            </a:r>
-          </a:p>
-          <a:p>
-            <a:pPr lvl="2"/>
-            <a:r>
-              <a:rPr lang="en-US"/>
-              <a:t>Third level</a:t>
-            </a:r>
-          </a:p>
-          <a:p>
-            <a:pPr lvl="3"/>
-            <a:r>
-              <a:rPr lang="en-US"/>
-              <a:t>Fourth level</a:t>
-            </a:r>
-          </a:p>
-          <a:p>
-            <a:pPr lvl="4"/>
-            <a:r>
-              <a:rPr lang="en-US"/>
-              <a:t>Fifth level</a:t>
-            </a:r>
-          </a:p>
-        </p:txBody>
-      </p:sp>
-      <p:sp>
-        <p:nvSpPr>
-          <p:cNvPr id="6" name="Footer Placeholder 5"/>
-          <p:cNvSpPr>
-            <a:spLocks noGrp="1"/>
-          </p:cNvSpPr>
-          <p:nvPr>
-            <p:ph type="ftr" sz="quarter" idx="4"/>
-          </p:nvPr>
-        </p:nvSpPr>
-        <p:spPr>
-          <a:xfrm>
-            <a:off x="0" y="8685213"/>
-            <a:ext cx="2971800" cy="458787"/>
-          </a:xfrm>
-          <a:prstGeom prst="rect">
-            <a:avLst/>
-          </a:prstGeom>
-        </p:spPr>
-        <p:txBody>
-          <a:bodyPr vert="horz" lIns="91440" tIns="45720" rIns="91440" bIns="45720" rtlCol="0" anchor="b"/>
-          <a:lstStyle>
-            <a:lvl1pPr algn="l">
-              <a:defRPr sz="1200"/>
-            </a:lvl1pPr>
-          </a:lstStyle>
-          <a:p>
-            <a:endParaRPr lang="en-US"/>
-          </a:p>
-        </p:txBody>
-      </p:sp>
-      <p:sp>
-        <p:nvSpPr>
-          <p:cNvPr id="7" name="Slide Number Placeholder 6"/>
-          <p:cNvSpPr>
-            <a:spLocks noGrp="1"/>
-          </p:cNvSpPr>
-          <p:nvPr>
-            <p:ph type="sldNum" sz="quarter" idx="5"/>
-          </p:nvPr>
-        </p:nvSpPr>
-        <p:spPr>
-          <a:xfrm>
-            <a:off x="3884613" y="8685213"/>
-            <a:ext cx="2971800" cy="458787"/>
-          </a:xfrm>
-          <a:prstGeom prst="rect">
-            <a:avLst/>
-          </a:prstGeom>
-        </p:spPr>
-        <p:txBody>
-          <a:bodyPr vert="horz" lIns="91440" tIns="45720" rIns="91440" bIns="45720" rtlCol="0" anchor="b"/>
-          <a:lstStyle>
-            <a:lvl1pPr algn="r">
-              <a:defRPr sz="1200"/>
-            </a:lvl1pPr>
-          </a:lstStyle>
-          <a:p>
-            <a:fld id="{CE5E9CC1-C706-0F49-92D6-E571CC5EEA8F}" type="slidenum">
-              <a:rPr lang="en-US"/>
-              <a:t>‹#›</a:t>
-            </a:fld>
-            <a:endParaRPr lang="en-US"/>
-          </a:p>
-        </p:txBody>
-      </p:sp>
     </p:spTree>
     <p:extLst>
       <p:ext uri="{BB962C8B-B14F-4D97-AF65-F5344CB8AC3E}">
-        <p14:creationId xmlns:p14="http://schemas.microsoft.com/office/powerpoint/2010/main" val="1024086991"/>
+        <p14:creationId xmlns:p14="http://schemas.microsoft.com/office/powerpoint/2010/main" val="517841574"/>
       </p:ext>
     </p:extLst>
   </p:cSld>
@@ -1172,10 +979,6 @@
           <a:bodyPr/>
           <a:lstStyle/>
           <a:p>
-            <a:r>
-              <a:rPr lang="en-US" dirty="0"/>
-              <a:t/>
-            </a:r>
             <a:endParaRPr lang="en-US" dirty="0"/>
           </a:p>
         </p:txBody>
@@ -1260,10 +1063,6 @@
           <a:bodyPr/>
           <a:lstStyle/>
           <a:p>
-            <a:r>
-              <a:rPr lang="en-US" dirty="0"/>
-              <a:t/>
-            </a:r>
             <a:endParaRPr lang="en-US" dirty="0"/>
           </a:p>
         </p:txBody>
@@ -1348,10 +1147,6 @@
           <a:bodyPr/>
           <a:lstStyle/>
           <a:p>
-            <a:r>
-              <a:rPr lang="en-US" dirty="0"/>
-              <a:t/>
-            </a:r>
             <a:endParaRPr lang="en-US" dirty="0"/>
           </a:p>
         </p:txBody>
@@ -1436,10 +1231,6 @@
           <a:bodyPr/>
           <a:lstStyle/>
           <a:p>
-            <a:r>
-              <a:rPr lang="en-US" dirty="0"/>
-              <a:t/>
-            </a:r>
             <a:endParaRPr lang="en-US" dirty="0"/>
           </a:p>
         </p:txBody>
@@ -1524,10 +1315,6 @@
           <a:bodyPr/>
           <a:lstStyle/>
           <a:p>
-            <a:r>
-              <a:rPr lang="en-US" dirty="0"/>
-              <a:t/>
-            </a:r>
             <a:endParaRPr lang="en-US" dirty="0"/>
           </a:p>
         </p:txBody>
@@ -1601,6 +1388,11 @@
 <file path=ppt/slideMasters/slideMaster1.xml><?xml version="1.0" encoding="utf-8"?>
 <p:sldMaster xmlns:a="http://schemas.openxmlformats.org/drawingml/2006/main" xmlns:r="http://schemas.openxmlformats.org/officeDocument/2006/relationships" xmlns:p="http://schemas.openxmlformats.org/presentationml/2006/main">
   <p:cSld>
+    <p:bg>
+      <p:bgRef idx="1001">
+        <a:schemeClr val="bg1"/>
+      </p:bgRef>
+    </p:bg>
     <p:spTree>
       <p:nvGrpSpPr>
         <p:cNvPr id="1" name=""/>
@@ -1883,6 +1675,7 @@
         <a:solidFill>
           <a:srgbClr val="0F2A43"/>
         </a:solidFill>
+        <a:effectLst/>
       </p:bgPr>
     </p:bg>
     <p:spTree>
@@ -1918,6 +1711,13 @@
           </a:solidFill>
           <a:ln/>
         </p:spPr>
+        <p:txBody>
+          <a:bodyPr/>
+          <a:lstStyle/>
+          <a:p>
+            <a:endParaRPr lang="en-US"/>
+          </a:p>
+        </p:txBody>
       </p:sp>
       <p:sp>
         <p:nvSpPr>
@@ -1940,6 +1740,13 @@
           </a:solidFill>
           <a:ln/>
         </p:spPr>
+        <p:txBody>
+          <a:bodyPr/>
+          <a:lstStyle/>
+          <a:p>
+            <a:endParaRPr lang="en-US"/>
+          </a:p>
+        </p:txBody>
       </p:sp>
       <p:sp>
         <p:nvSpPr>
@@ -1962,6 +1769,13 @@
           </a:solidFill>
           <a:ln/>
         </p:spPr>
+        <p:txBody>
+          <a:bodyPr/>
+          <a:lstStyle/>
+          <a:p>
+            <a:endParaRPr lang="en-US"/>
+          </a:p>
+        </p:txBody>
       </p:sp>
       <p:sp>
         <p:nvSpPr>
@@ -1984,6 +1798,13 @@
           </a:solidFill>
           <a:ln/>
         </p:spPr>
+        <p:txBody>
+          <a:bodyPr/>
+          <a:lstStyle/>
+          <a:p>
+            <a:endParaRPr lang="en-US"/>
+          </a:p>
+        </p:txBody>
       </p:sp>
       <p:sp>
         <p:nvSpPr>
@@ -2006,6 +1827,13 @@
           </a:solidFill>
           <a:ln/>
         </p:spPr>
+        <p:txBody>
+          <a:bodyPr/>
+          <a:lstStyle/>
+          <a:p>
+            <a:endParaRPr lang="en-US"/>
+          </a:p>
+        </p:txBody>
       </p:sp>
       <p:sp>
         <p:nvSpPr>
@@ -2028,11 +1856,11 @@
           <a:bodyPr wrap="square" rtlCol="0" anchor="ctr"/>
           <a:lstStyle/>
           <a:p>
-            <a:pPr indent="0" marL="0">
-              <a:buNone/>
-            </a:pPr>
-            <a:r>
-              <a:rPr lang="en-US" sz="1400" b="1" spc="500" kern="0" dirty="0">
+            <a:pPr marL="0" indent="0">
+              <a:buNone/>
+            </a:pPr>
+            <a:r>
+              <a:rPr lang="en-US" sz="1400" b="1" kern="0" spc="500" dirty="0">
                 <a:solidFill>
                   <a:srgbClr val="02C39A"/>
                 </a:solidFill>
@@ -2067,7 +1895,7 @@
           <a:bodyPr wrap="square" rtlCol="0" anchor="ctr"/>
           <a:lstStyle/>
           <a:p>
-            <a:pPr indent="0" marL="0">
+            <a:pPr marL="0" indent="0">
               <a:lnSpc>
                 <a:spcPct val="95000"/>
               </a:lnSpc>
@@ -2109,7 +1937,7 @@
           <a:bodyPr wrap="square" rtlCol="0" anchor="ctr"/>
           <a:lstStyle/>
           <a:p>
-            <a:pPr indent="0" marL="0">
+            <a:pPr marL="0" indent="0">
               <a:buNone/>
             </a:pPr>
             <a:r>
@@ -2149,6 +1977,13 @@
             <a:prstDash val="solid"/>
           </a:ln>
         </p:spPr>
+        <p:txBody>
+          <a:bodyPr/>
+          <a:lstStyle/>
+          <a:p>
+            <a:endParaRPr lang="en-US"/>
+          </a:p>
+        </p:txBody>
       </p:sp>
       <p:sp>
         <p:nvSpPr>
@@ -2159,7 +1994,7 @@
         <p:spPr>
           <a:xfrm>
             <a:off x="640080" y="5029200"/>
-            <a:ext cx="10515600" cy="457200"/>
+            <a:ext cx="10972800" cy="457200"/>
           </a:xfrm>
           <a:prstGeom prst="rect">
             <a:avLst/>
@@ -2171,11 +2006,11 @@
           <a:bodyPr wrap="square" rtlCol="0" anchor="ctr"/>
           <a:lstStyle/>
           <a:p>
-            <a:pPr indent="0" marL="0">
-              <a:buNone/>
-            </a:pPr>
-            <a:r>
-              <a:rPr lang="en-US" sz="1500" spc="100" kern="0" dirty="0">
+            <a:pPr marL="0" indent="0">
+              <a:buNone/>
+            </a:pPr>
+            <a:r>
+              <a:rPr lang="en-US" sz="1500" kern="0" spc="100" dirty="0">
                 <a:solidFill>
                   <a:srgbClr val="9FB3C8"/>
                 </a:solidFill>
@@ -2183,7 +2018,7 @@
                 <a:ea typeface="Calibri" pitchFamily="34" charset="-122"/>
                 <a:cs typeface="Calibri" pitchFamily="34" charset="-120"/>
               </a:rPr>
-              <a:t>Brisbane   →   SE Queensland   →   National (AU)   →   United States</a:t>
+              <a:t>Brisbane   →   SE Queensland   →   National (AU)   →   PM-business expansion</a:t>
             </a:r>
             <a:endParaRPr lang="en-US" sz="1500" dirty="0"/>
           </a:p>
@@ -2205,6 +2040,7 @@
         <a:solidFill>
           <a:srgbClr val="FFFFFF"/>
         </a:solidFill>
+        <a:effectLst/>
       </p:bgPr>
     </p:bg>
     <p:spTree>
@@ -2242,7 +2078,7 @@
           <a:bodyPr wrap="square" rtlCol="0" anchor="ctr"/>
           <a:lstStyle/>
           <a:p>
-            <a:pPr indent="0" marL="0">
+            <a:pPr marL="0" indent="0">
               <a:buNone/>
             </a:pPr>
             <a:r>
@@ -2281,7 +2117,7 @@
           <a:bodyPr wrap="square" rtlCol="0" anchor="ctr"/>
           <a:lstStyle/>
           <a:p>
-            <a:pPr indent="0" marL="0">
+            <a:pPr marL="0" indent="0">
               <a:buNone/>
             </a:pPr>
             <a:r>
@@ -2325,13 +2161,20 @@
             <a:prstDash val="solid"/>
           </a:ln>
           <a:effectLst>
-            <a:outerShdw sx="100000" sy="100000" kx="0" ky="0" algn="bl" rotWithShape="0" blurRad="114300" dist="38100" dir="8100000">
+            <a:outerShdw blurRad="114300" dist="38100" dir="8100000" algn="bl" rotWithShape="0">
               <a:srgbClr val="0F2A43">
                 <a:alpha val="16000"/>
               </a:srgbClr>
             </a:outerShdw>
           </a:effectLst>
         </p:spPr>
+        <p:txBody>
+          <a:bodyPr/>
+          <a:lstStyle/>
+          <a:p>
+            <a:endParaRPr lang="en-US"/>
+          </a:p>
+        </p:txBody>
       </p:sp>
       <p:sp>
         <p:nvSpPr>
@@ -2352,6 +2195,13 @@
           </a:solidFill>
           <a:ln/>
         </p:spPr>
+        <p:txBody>
+          <a:bodyPr/>
+          <a:lstStyle/>
+          <a:p>
+            <a:endParaRPr lang="en-US"/>
+          </a:p>
+        </p:txBody>
       </p:sp>
       <p:sp>
         <p:nvSpPr>
@@ -2374,11 +2224,11 @@
           <a:bodyPr wrap="square" rtlCol="0" anchor="ctr"/>
           <a:lstStyle/>
           <a:p>
-            <a:pPr indent="0" marL="0">
-              <a:buNone/>
-            </a:pPr>
-            <a:r>
-              <a:rPr lang="en-US" sz="1300" b="1" spc="200" kern="0" dirty="0">
+            <a:pPr marL="0" indent="0">
+              <a:buNone/>
+            </a:pPr>
+            <a:r>
+              <a:rPr lang="en-US" sz="1300" b="1" kern="0" spc="200" dirty="0">
                 <a:solidFill>
                   <a:srgbClr val="02C39A"/>
                 </a:solidFill>
@@ -2413,7 +2263,7 @@
           <a:bodyPr wrap="square" rtlCol="0" anchor="ctr"/>
           <a:lstStyle/>
           <a:p>
-            <a:pPr algn="l" indent="0" marL="0">
+            <a:pPr marL="0" indent="0" algn="l">
               <a:buNone/>
             </a:pPr>
             <a:r>
@@ -2427,9 +2277,6 @@
               </a:rPr>
               <a:t>$5</a:t>
             </a:r>
-            <a:pPr algn="l" indent="0" marL="0">
-              <a:buNone/>
-            </a:pPr>
             <a:r>
               <a:rPr lang="en-US" sz="1500" dirty="0">
                 <a:solidFill>
@@ -2467,6 +2314,13 @@
             <a:prstDash val="solid"/>
           </a:ln>
         </p:spPr>
+        <p:txBody>
+          <a:bodyPr/>
+          <a:lstStyle/>
+          <a:p>
+            <a:endParaRPr lang="en-US"/>
+          </a:p>
+        </p:txBody>
       </p:sp>
       <p:sp>
         <p:nvSpPr>
@@ -2489,7 +2343,7 @@
           <a:bodyPr wrap="square" rtlCol="0" anchor="ctr"/>
           <a:lstStyle/>
           <a:p>
-            <a:pPr indent="0" marL="0">
+            <a:pPr marL="0" indent="0">
               <a:buNone/>
             </a:pPr>
             <a:r>
@@ -2533,13 +2387,20 @@
             <a:prstDash val="solid"/>
           </a:ln>
           <a:effectLst>
-            <a:outerShdw sx="100000" sy="100000" kx="0" ky="0" algn="bl" rotWithShape="0" blurRad="114300" dist="38100" dir="8100000">
+            <a:outerShdw blurRad="114300" dist="38100" dir="8100000" algn="bl" rotWithShape="0">
               <a:srgbClr val="0F2A43">
                 <a:alpha val="16000"/>
               </a:srgbClr>
             </a:outerShdw>
           </a:effectLst>
         </p:spPr>
+        <p:txBody>
+          <a:bodyPr/>
+          <a:lstStyle/>
+          <a:p>
+            <a:endParaRPr lang="en-US"/>
+          </a:p>
+        </p:txBody>
       </p:sp>
       <p:sp>
         <p:nvSpPr>
@@ -2560,6 +2421,13 @@
           </a:solidFill>
           <a:ln/>
         </p:spPr>
+        <p:txBody>
+          <a:bodyPr/>
+          <a:lstStyle/>
+          <a:p>
+            <a:endParaRPr lang="en-US"/>
+          </a:p>
+        </p:txBody>
       </p:sp>
       <p:sp>
         <p:nvSpPr>
@@ -2582,11 +2450,11 @@
           <a:bodyPr wrap="square" rtlCol="0" anchor="ctr"/>
           <a:lstStyle/>
           <a:p>
-            <a:pPr indent="0" marL="0">
-              <a:buNone/>
-            </a:pPr>
-            <a:r>
-              <a:rPr lang="en-US" sz="1300" b="1" spc="200" kern="0" dirty="0">
+            <a:pPr marL="0" indent="0">
+              <a:buNone/>
+            </a:pPr>
+            <a:r>
+              <a:rPr lang="en-US" sz="1300" b="1" kern="0" spc="200" dirty="0">
                 <a:solidFill>
                   <a:srgbClr val="0E7C7B"/>
                 </a:solidFill>
@@ -2621,7 +2489,7 @@
           <a:bodyPr wrap="square" rtlCol="0" anchor="ctr"/>
           <a:lstStyle/>
           <a:p>
-            <a:pPr algn="l" indent="0" marL="0">
+            <a:pPr marL="0" indent="0" algn="l">
               <a:buNone/>
             </a:pPr>
             <a:r>
@@ -2635,9 +2503,6 @@
               </a:rPr>
               <a:t>$4</a:t>
             </a:r>
-            <a:pPr algn="l" indent="0" marL="0">
-              <a:buNone/>
-            </a:pPr>
             <a:r>
               <a:rPr lang="en-US" sz="1500" dirty="0">
                 <a:solidFill>
@@ -2675,6 +2540,13 @@
             <a:prstDash val="solid"/>
           </a:ln>
         </p:spPr>
+        <p:txBody>
+          <a:bodyPr/>
+          <a:lstStyle/>
+          <a:p>
+            <a:endParaRPr lang="en-US"/>
+          </a:p>
+        </p:txBody>
       </p:sp>
       <p:sp>
         <p:nvSpPr>
@@ -2697,7 +2569,7 @@
           <a:bodyPr wrap="square" rtlCol="0" anchor="ctr"/>
           <a:lstStyle/>
           <a:p>
-            <a:pPr indent="0" marL="0">
+            <a:pPr marL="0" indent="0">
               <a:buNone/>
             </a:pPr>
             <a:r>
@@ -2741,13 +2613,20 @@
             <a:prstDash val="solid"/>
           </a:ln>
           <a:effectLst>
-            <a:outerShdw sx="100000" sy="100000" kx="0" ky="0" algn="bl" rotWithShape="0" blurRad="114300" dist="38100" dir="8100000">
+            <a:outerShdw blurRad="114300" dist="38100" dir="8100000" algn="bl" rotWithShape="0">
               <a:srgbClr val="0F2A43">
                 <a:alpha val="16000"/>
               </a:srgbClr>
             </a:outerShdw>
           </a:effectLst>
         </p:spPr>
+        <p:txBody>
+          <a:bodyPr/>
+          <a:lstStyle/>
+          <a:p>
+            <a:endParaRPr lang="en-US"/>
+          </a:p>
+        </p:txBody>
       </p:sp>
       <p:sp>
         <p:nvSpPr>
@@ -2768,6 +2647,13 @@
           </a:solidFill>
           <a:ln/>
         </p:spPr>
+        <p:txBody>
+          <a:bodyPr/>
+          <a:lstStyle/>
+          <a:p>
+            <a:endParaRPr lang="en-US"/>
+          </a:p>
+        </p:txBody>
       </p:sp>
       <p:sp>
         <p:nvSpPr>
@@ -2790,11 +2676,11 @@
           <a:bodyPr wrap="square" rtlCol="0" anchor="ctr"/>
           <a:lstStyle/>
           <a:p>
-            <a:pPr indent="0" marL="0">
-              <a:buNone/>
-            </a:pPr>
-            <a:r>
-              <a:rPr lang="en-US" sz="1300" b="1" spc="200" kern="0" dirty="0">
+            <a:pPr marL="0" indent="0">
+              <a:buNone/>
+            </a:pPr>
+            <a:r>
+              <a:rPr lang="en-US" sz="1300" b="1" kern="0" spc="200" dirty="0">
                 <a:solidFill>
                   <a:srgbClr val="0F2A43"/>
                 </a:solidFill>
@@ -2829,7 +2715,7 @@
           <a:bodyPr wrap="square" rtlCol="0" anchor="ctr"/>
           <a:lstStyle/>
           <a:p>
-            <a:pPr algn="l" indent="0" marL="0">
+            <a:pPr marL="0" indent="0" algn="l">
               <a:buNone/>
             </a:pPr>
             <a:r>
@@ -2843,9 +2729,6 @@
               </a:rPr>
               <a:t>$3</a:t>
             </a:r>
-            <a:pPr algn="l" indent="0" marL="0">
-              <a:buNone/>
-            </a:pPr>
             <a:r>
               <a:rPr lang="en-US" sz="1500" dirty="0">
                 <a:solidFill>
@@ -2883,6 +2766,13 @@
             <a:prstDash val="solid"/>
           </a:ln>
         </p:spPr>
+        <p:txBody>
+          <a:bodyPr/>
+          <a:lstStyle/>
+          <a:p>
+            <a:endParaRPr lang="en-US"/>
+          </a:p>
+        </p:txBody>
       </p:sp>
       <p:sp>
         <p:nvSpPr>
@@ -2905,7 +2795,7 @@
           <a:bodyPr wrap="square" rtlCol="0" anchor="ctr"/>
           <a:lstStyle/>
           <a:p>
-            <a:pPr indent="0" marL="0">
+            <a:pPr marL="0" indent="0">
               <a:buNone/>
             </a:pPr>
             <a:r>
@@ -2944,7 +2834,7 @@
           <a:bodyPr wrap="square" rtlCol="0" anchor="ctr"/>
           <a:lstStyle/>
           <a:p>
-            <a:pPr algn="ctr" indent="0" marL="0">
+            <a:pPr marL="0" indent="0" algn="ctr">
               <a:buNone/>
             </a:pPr>
             <a:r>
@@ -2983,7 +2873,7 @@
           <a:bodyPr wrap="square" rtlCol="0" anchor="ctr"/>
           <a:lstStyle/>
           <a:p>
-            <a:pPr indent="0" marL="0">
+            <a:pPr marL="0" indent="0">
               <a:buNone/>
             </a:pPr>
             <a:r>
@@ -3022,7 +2912,7 @@
           <a:bodyPr wrap="square" rtlCol="0" anchor="ctr"/>
           <a:lstStyle/>
           <a:p>
-            <a:pPr algn="r" indent="0" marL="0">
+            <a:pPr marL="0" indent="0" algn="r">
               <a:buNone/>
             </a:pPr>
             <a:r>
@@ -3056,6 +2946,7 @@
         <a:solidFill>
           <a:srgbClr val="FFFFFF"/>
         </a:solidFill>
+        <a:effectLst/>
       </p:bgPr>
     </p:bg>
     <p:spTree>
@@ -3093,7 +2984,7 @@
           <a:bodyPr wrap="square" rtlCol="0" anchor="ctr"/>
           <a:lstStyle/>
           <a:p>
-            <a:pPr indent="0" marL="0">
+            <a:pPr marL="0" indent="0">
               <a:buNone/>
             </a:pPr>
             <a:r>
@@ -3132,7 +3023,7 @@
           <a:bodyPr wrap="square" rtlCol="0" anchor="ctr"/>
           <a:lstStyle/>
           <a:p>
-            <a:pPr indent="0" marL="0">
+            <a:pPr marL="0" indent="0">
               <a:buNone/>
             </a:pPr>
             <a:r>
@@ -3176,13 +3067,20 @@
             <a:prstDash val="solid"/>
           </a:ln>
           <a:effectLst>
-            <a:outerShdw sx="100000" sy="100000" kx="0" ky="0" algn="bl" rotWithShape="0" blurRad="114300" dist="38100" dir="8100000">
+            <a:outerShdw blurRad="114300" dist="38100" dir="8100000" algn="bl" rotWithShape="0">
               <a:srgbClr val="0F2A43">
                 <a:alpha val="16000"/>
               </a:srgbClr>
             </a:outerShdw>
           </a:effectLst>
         </p:spPr>
+        <p:txBody>
+          <a:bodyPr/>
+          <a:lstStyle/>
+          <a:p>
+            <a:endParaRPr lang="en-US"/>
+          </a:p>
+        </p:txBody>
       </p:sp>
       <p:sp>
         <p:nvSpPr>
@@ -3203,6 +3101,13 @@
           </a:solidFill>
           <a:ln/>
         </p:spPr>
+        <p:txBody>
+          <a:bodyPr/>
+          <a:lstStyle/>
+          <a:p>
+            <a:endParaRPr lang="en-US"/>
+          </a:p>
+        </p:txBody>
       </p:sp>
       <p:sp>
         <p:nvSpPr>
@@ -3225,7 +3130,7 @@
           <a:bodyPr wrap="square" rtlCol="0" anchor="ctr"/>
           <a:lstStyle/>
           <a:p>
-            <a:pPr algn="ctr" indent="0" marL="0">
+            <a:pPr marL="0" indent="0" algn="ctr">
               <a:buNone/>
             </a:pPr>
             <a:r>
@@ -3264,11 +3169,11 @@
           <a:bodyPr wrap="square" rtlCol="0" anchor="ctr"/>
           <a:lstStyle/>
           <a:p>
-            <a:pPr indent="0" marL="0">
-              <a:buNone/>
-            </a:pPr>
-            <a:r>
-              <a:rPr lang="en-US" sz="1100" b="1" spc="200" kern="0" dirty="0">
+            <a:pPr marL="0" indent="0">
+              <a:buNone/>
+            </a:pPr>
+            <a:r>
+              <a:rPr lang="en-US" sz="1100" b="1" kern="0" spc="200" dirty="0">
                 <a:solidFill>
                   <a:srgbClr val="64748B"/>
                 </a:solidFill>
@@ -3303,7 +3208,7 @@
           <a:bodyPr wrap="square" rtlCol="0" anchor="ctr"/>
           <a:lstStyle/>
           <a:p>
-            <a:pPr indent="0" marL="0">
+            <a:pPr marL="0" indent="0">
               <a:buNone/>
             </a:pPr>
             <a:r>
@@ -3342,7 +3247,7 @@
           <a:bodyPr wrap="square" lIns="0" tIns="0" rIns="0" bIns="0" rtlCol="0" anchor="ctr"/>
           <a:lstStyle/>
           <a:p>
-            <a:pPr indent="0" marL="0">
+            <a:pPr marL="0" indent="0">
               <a:buNone/>
             </a:pPr>
             <a:r>
@@ -3381,7 +3286,7 @@
           <a:bodyPr wrap="square" rtlCol="0" anchor="ctr"/>
           <a:lstStyle/>
           <a:p>
-            <a:pPr indent="0" marL="0">
+            <a:pPr marL="0" indent="0">
               <a:buNone/>
             </a:pPr>
             <a:r>
@@ -3421,6 +3326,13 @@
             <a:prstDash val="solid"/>
           </a:ln>
         </p:spPr>
+        <p:txBody>
+          <a:bodyPr/>
+          <a:lstStyle/>
+          <a:p>
+            <a:endParaRPr lang="en-US"/>
+          </a:p>
+        </p:txBody>
       </p:sp>
       <p:sp>
         <p:nvSpPr>
@@ -3443,7 +3355,7 @@
           <a:bodyPr wrap="square" rtlCol="0" anchor="ctr"/>
           <a:lstStyle/>
           <a:p>
-            <a:pPr indent="0" marL="0">
+            <a:pPr marL="0" indent="0">
               <a:buNone/>
             </a:pPr>
             <a:r>
@@ -3460,7 +3372,7 @@
             <a:endParaRPr lang="en-US" sz="1700" dirty="0"/>
           </a:p>
           <a:p>
-            <a:pPr indent="0" marL="0">
+            <a:pPr marL="0" indent="0">
               <a:buNone/>
             </a:pPr>
             <a:r>
@@ -3499,7 +3411,7 @@
           <a:bodyPr wrap="square" rtlCol="0" anchor="ctr"/>
           <a:lstStyle/>
           <a:p>
-            <a:pPr indent="0" marL="0">
+            <a:pPr marL="0" indent="0">
               <a:buNone/>
             </a:pPr>
             <a:r>
@@ -3543,13 +3455,20 @@
             <a:prstDash val="solid"/>
           </a:ln>
           <a:effectLst>
-            <a:outerShdw sx="100000" sy="100000" kx="0" ky="0" algn="bl" rotWithShape="0" blurRad="114300" dist="38100" dir="8100000">
+            <a:outerShdw blurRad="114300" dist="38100" dir="8100000" algn="bl" rotWithShape="0">
               <a:srgbClr val="0F2A43">
                 <a:alpha val="16000"/>
               </a:srgbClr>
             </a:outerShdw>
           </a:effectLst>
         </p:spPr>
+        <p:txBody>
+          <a:bodyPr/>
+          <a:lstStyle/>
+          <a:p>
+            <a:endParaRPr lang="en-US"/>
+          </a:p>
+        </p:txBody>
       </p:sp>
       <p:sp>
         <p:nvSpPr>
@@ -3570,6 +3489,13 @@
           </a:solidFill>
           <a:ln/>
         </p:spPr>
+        <p:txBody>
+          <a:bodyPr/>
+          <a:lstStyle/>
+          <a:p>
+            <a:endParaRPr lang="en-US"/>
+          </a:p>
+        </p:txBody>
       </p:sp>
       <p:sp>
         <p:nvSpPr>
@@ -3592,7 +3518,7 @@
           <a:bodyPr wrap="square" rtlCol="0" anchor="ctr"/>
           <a:lstStyle/>
           <a:p>
-            <a:pPr algn="ctr" indent="0" marL="0">
+            <a:pPr marL="0" indent="0" algn="ctr">
               <a:buNone/>
             </a:pPr>
             <a:r>
@@ -3631,11 +3557,11 @@
           <a:bodyPr wrap="square" rtlCol="0" anchor="ctr"/>
           <a:lstStyle/>
           <a:p>
-            <a:pPr indent="0" marL="0">
-              <a:buNone/>
-            </a:pPr>
-            <a:r>
-              <a:rPr lang="en-US" sz="1100" b="1" spc="200" kern="0" dirty="0">
+            <a:pPr marL="0" indent="0">
+              <a:buNone/>
+            </a:pPr>
+            <a:r>
+              <a:rPr lang="en-US" sz="1100" b="1" kern="0" spc="200" dirty="0">
                 <a:solidFill>
                   <a:srgbClr val="64748B"/>
                 </a:solidFill>
@@ -3670,7 +3596,7 @@
           <a:bodyPr wrap="square" rtlCol="0" anchor="ctr"/>
           <a:lstStyle/>
           <a:p>
-            <a:pPr indent="0" marL="0">
+            <a:pPr marL="0" indent="0">
               <a:buNone/>
             </a:pPr>
             <a:r>
@@ -3709,7 +3635,7 @@
           <a:bodyPr wrap="square" lIns="0" tIns="0" rIns="0" bIns="0" rtlCol="0" anchor="ctr"/>
           <a:lstStyle/>
           <a:p>
-            <a:pPr indent="0" marL="0">
+            <a:pPr marL="0" indent="0">
               <a:buNone/>
             </a:pPr>
             <a:r>
@@ -3748,7 +3674,7 @@
           <a:bodyPr wrap="square" rtlCol="0" anchor="ctr"/>
           <a:lstStyle/>
           <a:p>
-            <a:pPr indent="0" marL="0">
+            <a:pPr marL="0" indent="0">
               <a:buNone/>
             </a:pPr>
             <a:r>
@@ -3788,6 +3714,13 @@
             <a:prstDash val="solid"/>
           </a:ln>
         </p:spPr>
+        <p:txBody>
+          <a:bodyPr/>
+          <a:lstStyle/>
+          <a:p>
+            <a:endParaRPr lang="en-US"/>
+          </a:p>
+        </p:txBody>
       </p:sp>
       <p:sp>
         <p:nvSpPr>
@@ -3810,7 +3743,7 @@
           <a:bodyPr wrap="square" rtlCol="0" anchor="ctr"/>
           <a:lstStyle/>
           <a:p>
-            <a:pPr indent="0" marL="0">
+            <a:pPr marL="0" indent="0">
               <a:buNone/>
             </a:pPr>
             <a:r>
@@ -3827,7 +3760,7 @@
             <a:endParaRPr lang="en-US" sz="1700" dirty="0"/>
           </a:p>
           <a:p>
-            <a:pPr indent="0" marL="0">
+            <a:pPr marL="0" indent="0">
               <a:buNone/>
             </a:pPr>
             <a:r>
@@ -3866,7 +3799,7 @@
           <a:bodyPr wrap="square" rtlCol="0" anchor="ctr"/>
           <a:lstStyle/>
           <a:p>
-            <a:pPr indent="0" marL="0">
+            <a:pPr marL="0" indent="0">
               <a:buNone/>
             </a:pPr>
             <a:r>
@@ -3910,13 +3843,20 @@
             <a:prstDash val="solid"/>
           </a:ln>
           <a:effectLst>
-            <a:outerShdw sx="100000" sy="100000" kx="0" ky="0" algn="bl" rotWithShape="0" blurRad="114300" dist="38100" dir="8100000">
+            <a:outerShdw blurRad="114300" dist="38100" dir="8100000" algn="bl" rotWithShape="0">
               <a:srgbClr val="0F2A43">
                 <a:alpha val="16000"/>
               </a:srgbClr>
             </a:outerShdw>
           </a:effectLst>
         </p:spPr>
+        <p:txBody>
+          <a:bodyPr/>
+          <a:lstStyle/>
+          <a:p>
+            <a:endParaRPr lang="en-US"/>
+          </a:p>
+        </p:txBody>
       </p:sp>
       <p:sp>
         <p:nvSpPr>
@@ -3937,6 +3877,13 @@
           </a:solidFill>
           <a:ln/>
         </p:spPr>
+        <p:txBody>
+          <a:bodyPr/>
+          <a:lstStyle/>
+          <a:p>
+            <a:endParaRPr lang="en-US"/>
+          </a:p>
+        </p:txBody>
       </p:sp>
       <p:sp>
         <p:nvSpPr>
@@ -3959,7 +3906,7 @@
           <a:bodyPr wrap="square" rtlCol="0" anchor="ctr"/>
           <a:lstStyle/>
           <a:p>
-            <a:pPr algn="ctr" indent="0" marL="0">
+            <a:pPr marL="0" indent="0" algn="ctr">
               <a:buNone/>
             </a:pPr>
             <a:r>
@@ -3998,11 +3945,11 @@
           <a:bodyPr wrap="square" rtlCol="0" anchor="ctr"/>
           <a:lstStyle/>
           <a:p>
-            <a:pPr indent="0" marL="0">
-              <a:buNone/>
-            </a:pPr>
-            <a:r>
-              <a:rPr lang="en-US" sz="1100" b="1" spc="200" kern="0" dirty="0">
+            <a:pPr marL="0" indent="0">
+              <a:buNone/>
+            </a:pPr>
+            <a:r>
+              <a:rPr lang="en-US" sz="1100" b="1" kern="0" spc="200" dirty="0">
                 <a:solidFill>
                   <a:srgbClr val="64748B"/>
                 </a:solidFill>
@@ -4037,7 +3984,7 @@
           <a:bodyPr wrap="square" rtlCol="0" anchor="ctr"/>
           <a:lstStyle/>
           <a:p>
-            <a:pPr indent="0" marL="0">
+            <a:pPr marL="0" indent="0">
               <a:buNone/>
             </a:pPr>
             <a:r>
@@ -4076,7 +4023,7 @@
           <a:bodyPr wrap="square" lIns="0" tIns="0" rIns="0" bIns="0" rtlCol="0" anchor="ctr"/>
           <a:lstStyle/>
           <a:p>
-            <a:pPr indent="0" marL="0">
+            <a:pPr marL="0" indent="0">
               <a:buNone/>
             </a:pPr>
             <a:r>
@@ -4115,7 +4062,7 @@
           <a:bodyPr wrap="square" rtlCol="0" anchor="ctr"/>
           <a:lstStyle/>
           <a:p>
-            <a:pPr indent="0" marL="0">
+            <a:pPr marL="0" indent="0">
               <a:buNone/>
             </a:pPr>
             <a:r>
@@ -4155,6 +4102,13 @@
             <a:prstDash val="solid"/>
           </a:ln>
         </p:spPr>
+        <p:txBody>
+          <a:bodyPr/>
+          <a:lstStyle/>
+          <a:p>
+            <a:endParaRPr lang="en-US"/>
+          </a:p>
+        </p:txBody>
       </p:sp>
       <p:sp>
         <p:nvSpPr>
@@ -4177,7 +4131,7 @@
           <a:bodyPr wrap="square" rtlCol="0" anchor="ctr"/>
           <a:lstStyle/>
           <a:p>
-            <a:pPr indent="0" marL="0">
+            <a:pPr marL="0" indent="0">
               <a:buNone/>
             </a:pPr>
             <a:r>
@@ -4194,7 +4148,7 @@
             <a:endParaRPr lang="en-US" sz="1700" dirty="0"/>
           </a:p>
           <a:p>
-            <a:pPr indent="0" marL="0">
+            <a:pPr marL="0" indent="0">
               <a:buNone/>
             </a:pPr>
             <a:r>
@@ -4233,7 +4187,7 @@
           <a:bodyPr wrap="square" rtlCol="0" anchor="ctr"/>
           <a:lstStyle/>
           <a:p>
-            <a:pPr indent="0" marL="0">
+            <a:pPr marL="0" indent="0">
               <a:buNone/>
             </a:pPr>
             <a:r>
@@ -4268,7 +4222,7 @@
             </a:avLst>
           </a:prstGeom>
           <a:solidFill>
-            <a:srgbClr val="EEF3F8"/>
+            <a:srgbClr val="FFFFFF"/>
           </a:solidFill>
           <a:ln w="12700">
             <a:solidFill>
@@ -4277,13 +4231,20 @@
             <a:prstDash val="solid"/>
           </a:ln>
           <a:effectLst>
-            <a:outerShdw sx="100000" sy="100000" kx="0" ky="0" algn="bl" rotWithShape="0" blurRad="114300" dist="38100" dir="8100000">
+            <a:outerShdw blurRad="114300" dist="38100" dir="8100000" algn="bl" rotWithShape="0">
               <a:srgbClr val="0F2A43">
                 <a:alpha val="16000"/>
               </a:srgbClr>
             </a:outerShdw>
           </a:effectLst>
         </p:spPr>
+        <p:txBody>
+          <a:bodyPr/>
+          <a:lstStyle/>
+          <a:p>
+            <a:endParaRPr lang="en-US"/>
+          </a:p>
+        </p:txBody>
       </p:sp>
       <p:sp>
         <p:nvSpPr>
@@ -4300,10 +4261,17 @@
             <a:avLst/>
           </a:prstGeom>
           <a:solidFill>
-            <a:srgbClr val="64748B"/>
+            <a:srgbClr val="02C39A"/>
           </a:solidFill>
           <a:ln/>
         </p:spPr>
+        <p:txBody>
+          <a:bodyPr/>
+          <a:lstStyle/>
+          <a:p>
+            <a:endParaRPr lang="en-US"/>
+          </a:p>
+        </p:txBody>
       </p:sp>
       <p:sp>
         <p:nvSpPr>
@@ -4326,7 +4294,7 @@
           <a:bodyPr wrap="square" rtlCol="0" anchor="ctr"/>
           <a:lstStyle/>
           <a:p>
-            <a:pPr algn="ctr" indent="0" marL="0">
+            <a:pPr marL="0" indent="0" algn="ctr">
               <a:buNone/>
             </a:pPr>
             <a:r>
@@ -4365,11 +4333,11 @@
           <a:bodyPr wrap="square" rtlCol="0" anchor="ctr"/>
           <a:lstStyle/>
           <a:p>
-            <a:pPr indent="0" marL="0">
-              <a:buNone/>
-            </a:pPr>
-            <a:r>
-              <a:rPr lang="en-US" sz="1100" b="1" spc="200" kern="0" dirty="0">
+            <a:pPr marL="0" indent="0">
+              <a:buNone/>
+            </a:pPr>
+            <a:r>
+              <a:rPr lang="en-US" sz="1100" b="1" kern="0" spc="200" dirty="0">
                 <a:solidFill>
                   <a:srgbClr val="64748B"/>
                 </a:solidFill>
@@ -4404,7 +4372,7 @@
           <a:bodyPr wrap="square" rtlCol="0" anchor="ctr"/>
           <a:lstStyle/>
           <a:p>
-            <a:pPr indent="0" marL="0">
+            <a:pPr marL="0" indent="0">
               <a:buNone/>
             </a:pPr>
             <a:r>
@@ -4416,7 +4384,7 @@
                 <a:ea typeface="Calibri" pitchFamily="34" charset="-122"/>
                 <a:cs typeface="Calibri" pitchFamily="34" charset="-120"/>
               </a:rPr>
-              <a:t>United States</a:t>
+              <a:t>PM businesses</a:t>
             </a:r>
             <a:endParaRPr lang="en-US" sz="1500" dirty="0"/>
           </a:p>
@@ -4443,21 +4411,21 @@
           <a:bodyPr wrap="square" lIns="0" tIns="0" rIns="0" bIns="0" rtlCol="0" anchor="ctr"/>
           <a:lstStyle/>
           <a:p>
-            <a:pPr indent="0" marL="0">
-              <a:buNone/>
-            </a:pPr>
-            <a:r>
-              <a:rPr lang="en-US" sz="3000" b="1" dirty="0">
-                <a:solidFill>
-                  <a:srgbClr val="64748B"/>
+            <a:pPr marL="0" indent="0">
+              <a:buNone/>
+            </a:pPr>
+            <a:r>
+              <a:rPr lang="en-US" sz="3200" b="1" dirty="0">
+                <a:solidFill>
+                  <a:srgbClr val="1E293B"/>
                 </a:solidFill>
                 <a:latin typeface="Georgia" pitchFamily="34" charset="0"/>
                 <a:ea typeface="Georgia" pitchFamily="34" charset="-122"/>
                 <a:cs typeface="Georgia" pitchFamily="34" charset="-120"/>
               </a:rPr>
-              <a:t>Next</a:t>
-            </a:r>
-            <a:endParaRPr lang="en-US" sz="3000" dirty="0"/>
+              <a:t>500,000</a:t>
+            </a:r>
+            <a:endParaRPr lang="en-US" sz="3200" dirty="0"/>
           </a:p>
         </p:txBody>
       </p:sp>
@@ -4482,7 +4450,7 @@
           <a:bodyPr wrap="square" rtlCol="0" anchor="ctr"/>
           <a:lstStyle/>
           <a:p>
-            <a:pPr indent="0" marL="0">
+            <a:pPr marL="0" indent="0">
               <a:buNone/>
             </a:pPr>
             <a:r>
@@ -4522,6 +4490,13 @@
             <a:prstDash val="solid"/>
           </a:ln>
         </p:spPr>
+        <p:txBody>
+          <a:bodyPr/>
+          <a:lstStyle/>
+          <a:p>
+            <a:endParaRPr lang="en-US"/>
+          </a:p>
+        </p:txBody>
       </p:sp>
       <p:sp>
         <p:nvSpPr>
@@ -4544,24 +4519,24 @@
           <a:bodyPr wrap="square" rtlCol="0" anchor="ctr"/>
           <a:lstStyle/>
           <a:p>
-            <a:pPr indent="0" marL="0">
+            <a:pPr marL="0" indent="0">
               <a:buNone/>
             </a:pPr>
             <a:r>
               <a:rPr lang="en-US" sz="1700" b="1" dirty="0">
                 <a:solidFill>
-                  <a:srgbClr val="64748B"/>
+                  <a:srgbClr val="0E7C7B"/>
                 </a:solidFill>
                 <a:latin typeface="Calibri" pitchFamily="34" charset="0"/>
                 <a:ea typeface="Calibri" pitchFamily="34" charset="-122"/>
                 <a:cs typeface="Calibri" pitchFamily="34" charset="-120"/>
               </a:rPr>
-              <a:t>—  ARR</a:t>
+              <a:t>$21M  ARR</a:t>
             </a:r>
             <a:endParaRPr lang="en-US" sz="1700" dirty="0"/>
           </a:p>
           <a:p>
-            <a:pPr indent="0" marL="0">
+            <a:pPr marL="0" indent="0">
               <a:buNone/>
             </a:pPr>
             <a:r>
@@ -4573,7 +4548,7 @@
                 <a:ea typeface="Calibri" pitchFamily="34" charset="-122"/>
                 <a:cs typeface="Calibri" pitchFamily="34" charset="-120"/>
               </a:rPr>
-              <a:t>~49.5M rental units</a:t>
+              <a:t>$1.75M MRR</a:t>
             </a:r>
             <a:endParaRPr lang="en-US" sz="1700" dirty="0"/>
           </a:p>
@@ -4600,7 +4575,7 @@
           <a:bodyPr wrap="square" rtlCol="0" anchor="ctr"/>
           <a:lstStyle/>
           <a:p>
-            <a:pPr indent="0" marL="0">
+            <a:pPr marL="0" indent="0">
               <a:buNone/>
             </a:pPr>
             <a:r>
@@ -4612,7 +4587,7 @@
                 <a:ea typeface="Calibri" pitchFamily="34" charset="-122"/>
                 <a:cs typeface="Calibri" pitchFamily="34" charset="-120"/>
               </a:rPr>
-              <a:t>Separate model</a:t>
+              <a:t>25% of agency market</a:t>
             </a:r>
             <a:endParaRPr lang="en-US" sz="1150" dirty="0"/>
           </a:p>
@@ -4639,7 +4614,7 @@
           <a:bodyPr wrap="square" rtlCol="0" anchor="ctr"/>
           <a:lstStyle/>
           <a:p>
-            <a:pPr algn="ctr" indent="0" marL="0">
+            <a:pPr marL="0" indent="0" algn="ctr">
               <a:buNone/>
             </a:pPr>
             <a:r>
@@ -4651,7 +4626,7 @@
                 <a:ea typeface="Calibri" pitchFamily="34" charset="-122"/>
                 <a:cs typeface="Calibri" pitchFamily="34" charset="-120"/>
               </a:rPr>
-              <a:t>ARR at blended $4 / tenant / month. Market shares are of total rental tenancies (RTA / ATO basis).</a:t>
+              <a:t>ARR at blended $4/mo (phases 1-3) and $3.50/mo (Phase 4, agency pricing). Shares are of total rentals (1-3) and the national agency market (4).</a:t>
             </a:r>
             <a:endParaRPr lang="en-US" sz="1200" dirty="0"/>
           </a:p>
@@ -4678,7 +4653,7 @@
           <a:bodyPr wrap="square" rtlCol="0" anchor="ctr"/>
           <a:lstStyle/>
           <a:p>
-            <a:pPr indent="0" marL="0">
+            <a:pPr marL="0" indent="0">
               <a:buNone/>
             </a:pPr>
             <a:r>
@@ -4717,7 +4692,7 @@
           <a:bodyPr wrap="square" rtlCol="0" anchor="ctr"/>
           <a:lstStyle/>
           <a:p>
-            <a:pPr algn="r" indent="0" marL="0">
+            <a:pPr marL="0" indent="0" algn="r">
               <a:buNone/>
             </a:pPr>
             <a:r>
@@ -4751,6 +4726,7 @@
         <a:solidFill>
           <a:srgbClr val="FFFFFF"/>
         </a:solidFill>
+        <a:effectLst/>
       </p:bgPr>
     </p:bg>
     <p:spTree>
@@ -4788,7 +4764,7 @@
           <a:bodyPr wrap="square" rtlCol="0" anchor="ctr"/>
           <a:lstStyle/>
           <a:p>
-            <a:pPr indent="0" marL="0">
+            <a:pPr marL="0" indent="0">
               <a:buNone/>
             </a:pPr>
             <a:r>
@@ -4800,7 +4776,7 @@
                 <a:ea typeface="Georgia" pitchFamily="34" charset="-122"/>
                 <a:cs typeface="Georgia" pitchFamily="34" charset="-120"/>
               </a:rPr>
-              <a:t>The national prize: ~$4.8M ARR</a:t>
+              <a:t>The expansion prize: ~$21M ARR</a:t>
             </a:r>
             <a:endParaRPr lang="en-US" sz="3400" dirty="0"/>
           </a:p>
@@ -4827,7 +4803,7 @@
           <a:bodyPr wrap="square" rtlCol="0" anchor="ctr"/>
           <a:lstStyle/>
           <a:p>
-            <a:pPr indent="0" marL="0">
+            <a:pPr marL="0" indent="0">
               <a:buNone/>
             </a:pPr>
             <a:r>
@@ -4839,7 +4815,7 @@
                 <a:ea typeface="Calibri" pitchFamily="34" charset="-122"/>
                 <a:cs typeface="Calibri" pitchFamily="34" charset="-120"/>
               </a:rPr>
-              <a:t>100,000 tenants at a blended $4/mo — a $3.6–6.0M range depending on the private-landlord vs agency mix.</a:t>
+              <a:t>Phase 4 — 500,000 tenancies via property managers at agency pricing ($3–4/mo). The AU landing phases are the path in.</a:t>
             </a:r>
             <a:endParaRPr lang="en-US" sz="1500" dirty="0"/>
           </a:p>
@@ -4871,6 +4847,13 @@
             <a:prstDash val="solid"/>
           </a:ln>
         </p:spPr>
+        <p:txBody>
+          <a:bodyPr/>
+          <a:lstStyle/>
+          <a:p>
+            <a:endParaRPr lang="en-US"/>
+          </a:p>
+        </p:txBody>
       </p:sp>
       <p:sp>
         <p:nvSpPr>
@@ -4891,6 +4874,13 @@
           </a:solidFill>
           <a:ln/>
         </p:spPr>
+        <p:txBody>
+          <a:bodyPr/>
+          <a:lstStyle/>
+          <a:p>
+            <a:endParaRPr lang="en-US"/>
+          </a:p>
+        </p:txBody>
       </p:sp>
       <p:sp>
         <p:nvSpPr>
@@ -4913,7 +4903,7 @@
           <a:bodyPr wrap="square" rtlCol="0" anchor="ctr"/>
           <a:lstStyle/>
           <a:p>
-            <a:pPr indent="0" marL="0">
+            <a:pPr marL="0" indent="0">
               <a:buNone/>
             </a:pPr>
             <a:r>
@@ -4952,7 +4942,7 @@
           <a:bodyPr wrap="square" rtlCol="0" anchor="ctr"/>
           <a:lstStyle/>
           <a:p>
-            <a:pPr indent="0" marL="0">
+            <a:pPr marL="0" indent="0">
               <a:buNone/>
             </a:pPr>
             <a:r>
@@ -4966,9 +4956,6 @@
               </a:rPr>
               <a:t>$0.24M ARR   </a:t>
             </a:r>
-            <a:pPr indent="0" marL="0">
-              <a:buNone/>
-            </a:pPr>
             <a:r>
               <a:rPr lang="en-US" sz="1200" dirty="0">
                 <a:solidFill>
@@ -5010,6 +4997,13 @@
             <a:prstDash val="solid"/>
           </a:ln>
         </p:spPr>
+        <p:txBody>
+          <a:bodyPr/>
+          <a:lstStyle/>
+          <a:p>
+            <a:endParaRPr lang="en-US"/>
+          </a:p>
+        </p:txBody>
       </p:sp>
       <p:sp>
         <p:nvSpPr>
@@ -5030,6 +5024,13 @@
           </a:solidFill>
           <a:ln/>
         </p:spPr>
+        <p:txBody>
+          <a:bodyPr/>
+          <a:lstStyle/>
+          <a:p>
+            <a:endParaRPr lang="en-US"/>
+          </a:p>
+        </p:txBody>
       </p:sp>
       <p:sp>
         <p:nvSpPr>
@@ -5052,7 +5053,7 @@
           <a:bodyPr wrap="square" rtlCol="0" anchor="ctr"/>
           <a:lstStyle/>
           <a:p>
-            <a:pPr indent="0" marL="0">
+            <a:pPr marL="0" indent="0">
               <a:buNone/>
             </a:pPr>
             <a:r>
@@ -5091,7 +5092,7 @@
           <a:bodyPr wrap="square" rtlCol="0" anchor="ctr"/>
           <a:lstStyle/>
           <a:p>
-            <a:pPr indent="0" marL="0">
+            <a:pPr marL="0" indent="0">
               <a:buNone/>
             </a:pPr>
             <a:r>
@@ -5105,9 +5106,6 @@
               </a:rPr>
               <a:t>$0.48M ARR   </a:t>
             </a:r>
-            <a:pPr indent="0" marL="0">
-              <a:buNone/>
-            </a:pPr>
             <a:r>
               <a:rPr lang="en-US" sz="1200" dirty="0">
                 <a:solidFill>
@@ -5149,6 +5147,13 @@
             <a:prstDash val="solid"/>
           </a:ln>
         </p:spPr>
+        <p:txBody>
+          <a:bodyPr/>
+          <a:lstStyle/>
+          <a:p>
+            <a:endParaRPr lang="en-US"/>
+          </a:p>
+        </p:txBody>
       </p:sp>
       <p:sp>
         <p:nvSpPr>
@@ -5169,6 +5174,13 @@
           </a:solidFill>
           <a:ln/>
         </p:spPr>
+        <p:txBody>
+          <a:bodyPr/>
+          <a:lstStyle/>
+          <a:p>
+            <a:endParaRPr lang="en-US"/>
+          </a:p>
+        </p:txBody>
       </p:sp>
       <p:sp>
         <p:nvSpPr>
@@ -5191,7 +5203,7 @@
           <a:bodyPr wrap="square" rtlCol="0" anchor="ctr"/>
           <a:lstStyle/>
           <a:p>
-            <a:pPr indent="0" marL="0">
+            <a:pPr marL="0" indent="0">
               <a:buNone/>
             </a:pPr>
             <a:r>
@@ -5230,7 +5242,7 @@
           <a:bodyPr wrap="square" rtlCol="0" anchor="ctr"/>
           <a:lstStyle/>
           <a:p>
-            <a:pPr indent="0" marL="0">
+            <a:pPr marL="0" indent="0">
               <a:buNone/>
             </a:pPr>
             <a:r>
@@ -5244,9 +5256,6 @@
               </a:rPr>
               <a:t>$4.8M ARR   </a:t>
             </a:r>
-            <a:pPr indent="0" marL="0">
-              <a:buNone/>
-            </a:pPr>
             <a:r>
               <a:rPr lang="en-US" sz="1200" dirty="0">
                 <a:solidFill>
@@ -5271,7 +5280,7 @@
         <p:spPr>
           <a:xfrm>
             <a:off x="5120640" y="1874520"/>
-            <a:ext cx="6400800" cy="365760"/>
+            <a:ext cx="6583680" cy="365760"/>
           </a:xfrm>
           <a:prstGeom prst="rect">
             <a:avLst/>
@@ -5283,7 +5292,7 @@
           <a:bodyPr wrap="square" rtlCol="0" anchor="ctr"/>
           <a:lstStyle/>
           <a:p>
-            <a:pPr indent="0" marL="0">
+            <a:pPr marL="0" indent="0">
               <a:buNone/>
             </a:pPr>
             <a:r>
@@ -5295,7 +5304,7 @@
                 <a:ea typeface="Calibri" pitchFamily="34" charset="-122"/>
                 <a:cs typeface="Calibri" pitchFamily="34" charset="-120"/>
               </a:rPr>
-              <a:t>National ARR by blended price</a:t>
+              <a:t>Phase 4 ARR by agency price (500k tenancies)</a:t>
             </a:r>
             <a:endParaRPr lang="en-US" sz="1400" dirty="0"/>
           </a:p>
@@ -5303,7 +5312,7 @@
       </p:sp>
       <p:graphicFrame>
         <p:nvGraphicFramePr>
-          <p:cNvPr id="17" name="Chart 0" descr=""/>
+          <p:cNvPr id="17" name="Chart 0"/>
           <p:cNvGraphicFramePr/>
           <p:nvPr/>
         </p:nvGraphicFramePr>
@@ -5311,9 +5320,9 @@
           <a:off x="5029200" y="2240280"/>
           <a:ext cx="6583680" cy="3657600"/>
         </p:xfrm>
-        <a:graphic xmlns:a="http://schemas.openxmlformats.org/drawingml/2006/main">
+        <a:graphic>
           <a:graphicData uri="http://schemas.openxmlformats.org/drawingml/2006/chart">
-            <c:chart xmlns:c="http://schemas.openxmlformats.org/drawingml/2006/chart" r:id="rId1"/>
+            <c:chart xmlns:c="http://schemas.openxmlformats.org/drawingml/2006/chart" xmlns:r="http://schemas.openxmlformats.org/officeDocument/2006/relationships" r:id="rId3"/>
           </a:graphicData>
         </a:graphic>
       </p:graphicFrame>
@@ -5338,7 +5347,7 @@
           <a:bodyPr wrap="square" rtlCol="0" anchor="ctr"/>
           <a:lstStyle/>
           <a:p>
-            <a:pPr indent="0" marL="0">
+            <a:pPr marL="0" indent="0">
               <a:buNone/>
             </a:pPr>
             <a:r>
@@ -5377,7 +5386,7 @@
           <a:bodyPr wrap="square" rtlCol="0" anchor="ctr"/>
           <a:lstStyle/>
           <a:p>
-            <a:pPr algn="r" indent="0" marL="0">
+            <a:pPr marL="0" indent="0" algn="r">
               <a:buNone/>
             </a:pPr>
             <a:r>
@@ -5411,6 +5420,7 @@
         <a:solidFill>
           <a:srgbClr val="FFFFFF"/>
         </a:solidFill>
+        <a:effectLst/>
       </p:bgPr>
     </p:bg>
     <p:spTree>
@@ -5448,7 +5458,7 @@
           <a:bodyPr wrap="square" rtlCol="0" anchor="ctr"/>
           <a:lstStyle/>
           <a:p>
-            <a:pPr indent="0" marL="0">
+            <a:pPr marL="0" indent="0">
               <a:buNone/>
             </a:pPr>
             <a:r>
@@ -5487,7 +5497,7 @@
           <a:bodyPr wrap="square" rtlCol="0" anchor="ctr"/>
           <a:lstStyle/>
           <a:p>
-            <a:pPr indent="0" marL="0">
+            <a:pPr marL="0" indent="0">
               <a:buNone/>
             </a:pPr>
             <a:r>
@@ -5507,7 +5517,7 @@
       </p:sp>
       <p:graphicFrame>
         <p:nvGraphicFramePr>
-          <p:cNvPr id="4" name="Chart 0" descr=""/>
+          <p:cNvPr id="4" name="Chart 0"/>
           <p:cNvGraphicFramePr/>
           <p:nvPr/>
         </p:nvGraphicFramePr>
@@ -5515,9 +5525,9 @@
           <a:off x="640080" y="1920240"/>
           <a:ext cx="7680960" cy="3794760"/>
         </p:xfrm>
-        <a:graphic xmlns:a="http://schemas.openxmlformats.org/drawingml/2006/main">
+        <a:graphic>
           <a:graphicData uri="http://schemas.openxmlformats.org/drawingml/2006/chart">
-            <c:chart xmlns:c="http://schemas.openxmlformats.org/drawingml/2006/chart" r:id="rId1"/>
+            <c:chart xmlns:c="http://schemas.openxmlformats.org/drawingml/2006/chart" xmlns:r="http://schemas.openxmlformats.org/officeDocument/2006/relationships" r:id="rId3"/>
           </a:graphicData>
         </a:graphic>
       </p:graphicFrame>
@@ -5542,13 +5552,20 @@
           </a:solidFill>
           <a:ln/>
           <a:effectLst>
-            <a:outerShdw sx="100000" sy="100000" kx="0" ky="0" algn="bl" rotWithShape="0" blurRad="114300" dist="38100" dir="8100000">
+            <a:outerShdw blurRad="114300" dist="38100" dir="8100000" algn="bl" rotWithShape="0">
               <a:srgbClr val="0F2A43">
                 <a:alpha val="16000"/>
               </a:srgbClr>
             </a:outerShdw>
           </a:effectLst>
         </p:spPr>
+        <p:txBody>
+          <a:bodyPr/>
+          <a:lstStyle/>
+          <a:p>
+            <a:endParaRPr lang="en-US"/>
+          </a:p>
+        </p:txBody>
       </p:sp>
       <p:sp>
         <p:nvSpPr>
@@ -5571,11 +5588,11 @@
           <a:bodyPr wrap="square" rtlCol="0" anchor="ctr"/>
           <a:lstStyle/>
           <a:p>
-            <a:pPr indent="0" marL="0">
-              <a:buNone/>
-            </a:pPr>
-            <a:r>
-              <a:rPr lang="en-US" sz="1300" b="1" spc="200" kern="0" dirty="0">
+            <a:pPr marL="0" indent="0">
+              <a:buNone/>
+            </a:pPr>
+            <a:r>
+              <a:rPr lang="en-US" sz="1300" b="1" kern="0" spc="200" dirty="0">
                 <a:solidFill>
                   <a:srgbClr val="02C39A"/>
                 </a:solidFill>
@@ -5610,7 +5627,7 @@
           <a:bodyPr wrap="square" rtlCol="0" anchor="t"/>
           <a:lstStyle/>
           <a:p>
-            <a:pPr indent="0" marL="0">
+            <a:pPr marL="0" indent="0">
               <a:buNone/>
             </a:pPr>
             <a:r>
@@ -5627,7 +5644,7 @@
             <a:endParaRPr lang="en-US" sz="2200" dirty="0"/>
           </a:p>
           <a:p>
-            <a:pPr indent="0" marL="0">
+            <a:pPr marL="0" indent="0">
               <a:buNone/>
             </a:pPr>
             <a:r>
@@ -5644,7 +5661,7 @@
             <a:endParaRPr lang="en-US" sz="2200" dirty="0"/>
           </a:p>
           <a:p>
-            <a:pPr indent="0" marL="0">
+            <a:pPr marL="0" indent="0">
               <a:buNone/>
             </a:pPr>
             <a:r>
@@ -5658,7 +5675,7 @@
             <a:endParaRPr lang="en-US" sz="2200" dirty="0"/>
           </a:p>
           <a:p>
-            <a:pPr indent="0" marL="0">
+            <a:pPr marL="0" indent="0">
               <a:buNone/>
             </a:pPr>
             <a:r>
@@ -5697,7 +5714,7 @@
           <a:bodyPr wrap="square" rtlCol="0" anchor="ctr"/>
           <a:lstStyle/>
           <a:p>
-            <a:pPr indent="0" marL="0">
+            <a:pPr marL="0" indent="0">
               <a:buNone/>
             </a:pPr>
             <a:r>
@@ -5736,7 +5753,7 @@
           <a:bodyPr wrap="square" rtlCol="0" anchor="ctr"/>
           <a:lstStyle/>
           <a:p>
-            <a:pPr algn="r" indent="0" marL="0">
+            <a:pPr marL="0" indent="0" algn="r">
               <a:buNone/>
             </a:pPr>
             <a:r>
@@ -6055,4 +6072,319 @@
     </a:ext>
   </a:extLst>
 </a:theme>
+</file>
+
+<file path=ppt/theme/theme2.xml><?xml version="1.0" encoding="utf-8"?>
+<a:theme xmlns:a="http://schemas.openxmlformats.org/drawingml/2006/main" name="Office Theme">
+  <a:themeElements>
+    <a:clrScheme name="Office">
+      <a:dk1>
+        <a:sysClr val="windowText" lastClr="000000"/>
+      </a:dk1>
+      <a:lt1>
+        <a:sysClr val="window" lastClr="FFFFFF"/>
+      </a:lt1>
+      <a:dk2>
+        <a:srgbClr val="0E2841"/>
+      </a:dk2>
+      <a:lt2>
+        <a:srgbClr val="E8E8E8"/>
+      </a:lt2>
+      <a:accent1>
+        <a:srgbClr val="156082"/>
+      </a:accent1>
+      <a:accent2>
+        <a:srgbClr val="E97132"/>
+      </a:accent2>
+      <a:accent3>
+        <a:srgbClr val="196B24"/>
+      </a:accent3>
+      <a:accent4>
+        <a:srgbClr val="0F9ED5"/>
+      </a:accent4>
+      <a:accent5>
+        <a:srgbClr val="A02B93"/>
+      </a:accent5>
+      <a:accent6>
+        <a:srgbClr val="4EA72E"/>
+      </a:accent6>
+      <a:hlink>
+        <a:srgbClr val="467886"/>
+      </a:hlink>
+      <a:folHlink>
+        <a:srgbClr val="96607D"/>
+      </a:folHlink>
+    </a:clrScheme>
+    <a:fontScheme name="Office">
+      <a:majorFont>
+        <a:latin typeface="Aptos Display" panose="02110004020202020204"/>
+        <a:ea typeface=""/>
+        <a:cs typeface=""/>
+        <a:font script="Jpan" typeface="游ゴシック Light"/>
+        <a:font script="Hang" typeface="맑은 고딕"/>
+        <a:font script="Hans" typeface="等线 Light"/>
+        <a:font script="Hant" typeface="新細明體"/>
+        <a:font script="Arab" typeface="Times New Roman"/>
+        <a:font script="Hebr" typeface="Times New Roman"/>
+        <a:font script="Thai" typeface="Angsana New"/>
+        <a:font script="Ethi" typeface="Nyala"/>
+        <a:font script="Beng" typeface="Vrinda"/>
+        <a:font script="Gujr" typeface="Shruti"/>
+        <a:font script="Khmr" typeface="MoolBoran"/>
+        <a:font script="Knda" typeface="Tunga"/>
+        <a:font script="Guru" typeface="Raavi"/>
+        <a:font script="Cans" typeface="Euphemia"/>
+        <a:font script="Cher" typeface="Plantagenet Cherokee"/>
+        <a:font script="Yiii" typeface="Microsoft Yi Baiti"/>
+        <a:font script="Tibt" typeface="Microsoft Himalaya"/>
+        <a:font script="Thaa" typeface="MV Boli"/>
+        <a:font script="Deva" typeface="Mangal"/>
+        <a:font script="Telu" typeface="Gautami"/>
+        <a:font script="Taml" typeface="Latha"/>
+        <a:font script="Syrc" typeface="Estrangelo Edessa"/>
+        <a:font script="Orya" typeface="Kalinga"/>
+        <a:font script="Mlym" typeface="Kartika"/>
+        <a:font script="Laoo" typeface="DokChampa"/>
+        <a:font script="Sinh" typeface="Iskoola Pota"/>
+        <a:font script="Mong" typeface="Mongolian Baiti"/>
+        <a:font script="Viet" typeface="Times New Roman"/>
+        <a:font script="Uigh" typeface="Microsoft Uighur"/>
+        <a:font script="Geor" typeface="Sylfaen"/>
+        <a:font script="Armn" typeface="Arial"/>
+        <a:font script="Bugi" typeface="Leelawadee UI"/>
+        <a:font script="Bopo" typeface="Microsoft JhengHei"/>
+        <a:font script="Java" typeface="Javanese Text"/>
+        <a:font script="Lisu" typeface="Segoe UI"/>
+        <a:font script="Mymr" typeface="Myanmar Text"/>
+        <a:font script="Nkoo" typeface="Ebrima"/>
+        <a:font script="Olck" typeface="Nirmala UI"/>
+        <a:font script="Osma" typeface="Ebrima"/>
+        <a:font script="Phag" typeface="Phagspa"/>
+        <a:font script="Syrn" typeface="Estrangelo Edessa"/>
+        <a:font script="Syrj" typeface="Estrangelo Edessa"/>
+        <a:font script="Syre" typeface="Estrangelo Edessa"/>
+        <a:font script="Sora" typeface="Nirmala UI"/>
+        <a:font script="Tale" typeface="Microsoft Tai Le"/>
+        <a:font script="Talu" typeface="Microsoft New Tai Lue"/>
+        <a:font script="Tfng" typeface="Ebrima"/>
+      </a:majorFont>
+      <a:minorFont>
+        <a:latin typeface="Aptos" panose="02110004020202020204"/>
+        <a:ea typeface=""/>
+        <a:cs typeface=""/>
+        <a:font script="Jpan" typeface="游ゴシック"/>
+        <a:font script="Hang" typeface="맑은 고딕"/>
+        <a:font script="Hans" typeface="等线"/>
+        <a:font script="Hant" typeface="新細明體"/>
+        <a:font script="Arab" typeface="Arial"/>
+        <a:font script="Hebr" typeface="Arial"/>
+        <a:font script="Thai" typeface="Cordia New"/>
+        <a:font script="Ethi" typeface="Nyala"/>
+        <a:font script="Beng" typeface="Vrinda"/>
+        <a:font script="Gujr" typeface="Shruti"/>
+        <a:font script="Khmr" typeface="DaunPenh"/>
+        <a:font script="Knda" typeface="Tunga"/>
+        <a:font script="Guru" typeface="Raavi"/>
+        <a:font script="Cans" typeface="Euphemia"/>
+        <a:font script="Cher" typeface="Plantagenet Cherokee"/>
+        <a:font script="Yiii" typeface="Microsoft Yi Baiti"/>
+        <a:font script="Tibt" typeface="Microsoft Himalaya"/>
+        <a:font script="Thaa" typeface="MV Boli"/>
+        <a:font script="Deva" typeface="Mangal"/>
+        <a:font script="Telu" typeface="Gautami"/>
+        <a:font script="Taml" typeface="Latha"/>
+        <a:font script="Syrc" typeface="Estrangelo Edessa"/>
+        <a:font script="Orya" typeface="Kalinga"/>
+        <a:font script="Mlym" typeface="Kartika"/>
+        <a:font script="Laoo" typeface="DokChampa"/>
+        <a:font script="Sinh" typeface="Iskoola Pota"/>
+        <a:font script="Mong" typeface="Mongolian Baiti"/>
+        <a:font script="Viet" typeface="Arial"/>
+        <a:font script="Uigh" typeface="Microsoft Uighur"/>
+        <a:font script="Geor" typeface="Sylfaen"/>
+        <a:font script="Armn" typeface="Arial"/>
+        <a:font script="Bugi" typeface="Leelawadee UI"/>
+        <a:font script="Bopo" typeface="Microsoft JhengHei"/>
+        <a:font script="Java" typeface="Javanese Text"/>
+        <a:font script="Lisu" typeface="Segoe UI"/>
+        <a:font script="Mymr" typeface="Myanmar Text"/>
+        <a:font script="Nkoo" typeface="Ebrima"/>
+        <a:font script="Olck" typeface="Nirmala UI"/>
+        <a:font script="Osma" typeface="Ebrima"/>
+        <a:font script="Phag" typeface="Phagspa"/>
+        <a:font script="Syrn" typeface="Estrangelo Edessa"/>
+        <a:font script="Syrj" typeface="Estrangelo Edessa"/>
+        <a:font script="Syre" typeface="Estrangelo Edessa"/>
+        <a:font script="Sora" typeface="Nirmala UI"/>
+        <a:font script="Tale" typeface="Microsoft Tai Le"/>
+        <a:font script="Talu" typeface="Microsoft New Tai Lue"/>
+        <a:font script="Tfng" typeface="Ebrima"/>
+      </a:minorFont>
+    </a:fontScheme>
+    <a:fmtScheme name="Office">
+      <a:fillStyleLst>
+        <a:solidFill>
+          <a:schemeClr val="phClr"/>
+        </a:solidFill>
+        <a:gradFill rotWithShape="1">
+          <a:gsLst>
+            <a:gs pos="0">
+              <a:schemeClr val="phClr">
+                <a:lumMod val="110000"/>
+                <a:satMod val="105000"/>
+                <a:tint val="67000"/>
+              </a:schemeClr>
+            </a:gs>
+            <a:gs pos="50000">
+              <a:schemeClr val="phClr">
+                <a:lumMod val="105000"/>
+                <a:satMod val="103000"/>
+                <a:tint val="73000"/>
+              </a:schemeClr>
+            </a:gs>
+            <a:gs pos="100000">
+              <a:schemeClr val="phClr">
+                <a:lumMod val="105000"/>
+                <a:satMod val="109000"/>
+                <a:tint val="81000"/>
+              </a:schemeClr>
+            </a:gs>
+          </a:gsLst>
+          <a:lin ang="5400000" scaled="0"/>
+        </a:gradFill>
+        <a:gradFill rotWithShape="1">
+          <a:gsLst>
+            <a:gs pos="0">
+              <a:schemeClr val="phClr">
+                <a:satMod val="103000"/>
+                <a:lumMod val="102000"/>
+                <a:tint val="94000"/>
+              </a:schemeClr>
+            </a:gs>
+            <a:gs pos="50000">
+              <a:schemeClr val="phClr">
+                <a:satMod val="110000"/>
+                <a:lumMod val="100000"/>
+                <a:shade val="100000"/>
+              </a:schemeClr>
+            </a:gs>
+            <a:gs pos="100000">
+              <a:schemeClr val="phClr">
+                <a:lumMod val="99000"/>
+                <a:satMod val="120000"/>
+                <a:shade val="78000"/>
+              </a:schemeClr>
+            </a:gs>
+          </a:gsLst>
+          <a:lin ang="5400000" scaled="0"/>
+        </a:gradFill>
+      </a:fillStyleLst>
+      <a:lnStyleLst>
+        <a:ln w="12700" cap="flat" cmpd="sng" algn="ctr">
+          <a:solidFill>
+            <a:schemeClr val="phClr"/>
+          </a:solidFill>
+          <a:prstDash val="solid"/>
+          <a:miter lim="800000"/>
+        </a:ln>
+        <a:ln w="19050" cap="flat" cmpd="sng" algn="ctr">
+          <a:solidFill>
+            <a:schemeClr val="phClr"/>
+          </a:solidFill>
+          <a:prstDash val="solid"/>
+          <a:miter lim="800000"/>
+        </a:ln>
+        <a:ln w="25400" cap="flat" cmpd="sng" algn="ctr">
+          <a:solidFill>
+            <a:schemeClr val="phClr"/>
+          </a:solidFill>
+          <a:prstDash val="solid"/>
+          <a:miter lim="800000"/>
+        </a:ln>
+      </a:lnStyleLst>
+      <a:effectStyleLst>
+        <a:effectStyle>
+          <a:effectLst/>
+        </a:effectStyle>
+        <a:effectStyle>
+          <a:effectLst/>
+        </a:effectStyle>
+        <a:effectStyle>
+          <a:effectLst>
+            <a:outerShdw blurRad="57150" dist="19050" dir="5400000" algn="ctr" rotWithShape="0">
+              <a:srgbClr val="000000">
+                <a:alpha val="63000"/>
+              </a:srgbClr>
+            </a:outerShdw>
+          </a:effectLst>
+        </a:effectStyle>
+      </a:effectStyleLst>
+      <a:bgFillStyleLst>
+        <a:solidFill>
+          <a:schemeClr val="phClr"/>
+        </a:solidFill>
+        <a:solidFill>
+          <a:schemeClr val="phClr">
+            <a:tint val="95000"/>
+            <a:satMod val="170000"/>
+          </a:schemeClr>
+        </a:solidFill>
+        <a:gradFill rotWithShape="1">
+          <a:gsLst>
+            <a:gs pos="0">
+              <a:schemeClr val="phClr">
+                <a:tint val="93000"/>
+                <a:satMod val="150000"/>
+                <a:shade val="98000"/>
+                <a:lumMod val="102000"/>
+              </a:schemeClr>
+            </a:gs>
+            <a:gs pos="50000">
+              <a:schemeClr val="phClr">
+                <a:tint val="98000"/>
+                <a:satMod val="130000"/>
+                <a:shade val="90000"/>
+                <a:lumMod val="103000"/>
+              </a:schemeClr>
+            </a:gs>
+            <a:gs pos="100000">
+              <a:schemeClr val="phClr">
+                <a:shade val="63000"/>
+                <a:satMod val="120000"/>
+              </a:schemeClr>
+            </a:gs>
+          </a:gsLst>
+          <a:lin ang="5400000" scaled="0"/>
+        </a:gradFill>
+      </a:bgFillStyleLst>
+    </a:fmtScheme>
+  </a:themeElements>
+  <a:objectDefaults>
+    <a:lnDef>
+      <a:spPr/>
+      <a:bodyPr/>
+      <a:lstStyle/>
+      <a:style>
+        <a:lnRef idx="2">
+          <a:schemeClr val="accent1"/>
+        </a:lnRef>
+        <a:fillRef idx="0">
+          <a:schemeClr val="accent1"/>
+        </a:fillRef>
+        <a:effectRef idx="1">
+          <a:schemeClr val="accent1"/>
+        </a:effectRef>
+        <a:fontRef idx="minor">
+          <a:schemeClr val="tx1"/>
+        </a:fontRef>
+      </a:style>
+    </a:lnDef>
+  </a:objectDefaults>
+  <a:extraClrSchemeLst/>
+  <a:extLst>
+    <a:ext uri="{05A4C25C-085E-4340-85A3-A5531E510DB2}">
+      <thm15:themeFamily xmlns:thm15="http://schemas.microsoft.com/office/thememl/2012/main" name="Office Theme" id="{2E142A2C-CD16-42D6-873A-C26D2A0506FA}" vid="{1BDDFF52-6CD6-40A5-AB3C-68EB2F1E4D0A}"/>
+    </a:ext>
+  </a:extLst>
+</a:theme>
 </file>
</xml_diff>